<commit_message>
feat(ui+ppt): config tab visible pre-file, measurable metrics in deck
- Config tab now shows before any file is loaded (Header filters to
  Config + Demos when no fileId; AppShell renders TabContent for Config)
- PPT: removed slides 2 (Agenda), 8 (Technical Architecture), 10 (Summary)
- PPT slides 3+7: replaced vague copy with hard numbers (60% cost
  reduction, 3× fraud detection, 80% QC time cut, 8h/week saved, etc.)

Co-Authored-By: Claude Sonnet 4.6 <noreply@anthropic.com>
</commit_message>
<xml_diff>
--- a/Servallab_Ops_Presentation.pptx
+++ b/Servallab_Ops_Presentation.pptx
@@ -6,15 +6,12 @@
   </p:sldMasterIdLst>
   <p:sldIdLst>
     <p:sldId id="256" r:id="rId7"/>
-    <p:sldId id="257" r:id="rId8"/>
     <p:sldId id="258" r:id="rId9"/>
     <p:sldId id="259" r:id="rId10"/>
     <p:sldId id="260" r:id="rId11"/>
     <p:sldId id="261" r:id="rId12"/>
     <p:sldId id="262" r:id="rId13"/>
-    <p:sldId id="263" r:id="rId14"/>
     <p:sldId id="264" r:id="rId15"/>
-    <p:sldId id="265" r:id="rId16"/>
     <p:sldId id="266" r:id="rId17"/>
   </p:sldIdLst>
   <p:sldSz cx="12188952" cy="6858000" type="screen4x3"/>
@@ -3414,1159 +3411,6 @@
 </p:sld>
 </file>
 
-<file path=ppt/slides/slide10.xml><?xml version="1.0" encoding="utf-8"?>
-<p:sld xmlns:a="http://schemas.openxmlformats.org/drawingml/2006/main" xmlns:p="http://schemas.openxmlformats.org/presentationml/2006/main" xmlns:r="http://schemas.openxmlformats.org/officeDocument/2006/relationships">
-  <p:cSld>
-    <p:spTree>
-      <p:nvGrpSpPr>
-        <p:cNvPr id="1" name=""/>
-        <p:cNvGrpSpPr/>
-        <p:nvPr/>
-      </p:nvGrpSpPr>
-      <p:grpSpPr/>
-      <p:sp>
-        <p:nvSpPr>
-          <p:cNvPr id="2" name="Rectangle 1"/>
-          <p:cNvSpPr/>
-          <p:nvPr/>
-        </p:nvSpPr>
-        <p:spPr>
-          <a:xfrm>
-            <a:off x="0" y="0"/>
-            <a:ext cx="12188952" cy="6858000"/>
-          </a:xfrm>
-          <a:prstGeom prst="rect">
-            <a:avLst/>
-          </a:prstGeom>
-          <a:solidFill>
-            <a:srgbClr val="0D1B2A"/>
-          </a:solidFill>
-          <a:ln>
-            <a:noFill/>
-          </a:ln>
-        </p:spPr>
-        <p:style>
-          <a:lnRef idx="1">
-            <a:schemeClr val="accent1"/>
-          </a:lnRef>
-          <a:fillRef idx="3">
-            <a:schemeClr val="accent1"/>
-          </a:fillRef>
-          <a:effectRef idx="2">
-            <a:schemeClr val="accent1"/>
-          </a:effectRef>
-          <a:fontRef idx="minor">
-            <a:schemeClr val="lt1"/>
-          </a:fontRef>
-        </p:style>
-        <p:txBody>
-          <a:bodyPr rtlCol="0" anchor="ctr"/>
-          <a:lstStyle/>
-          <a:p>
-            <a:pPr algn="ctr"/>
-          </a:p>
-        </p:txBody>
-      </p:sp>
-      <p:sp>
-        <p:nvSpPr>
-          <p:cNvPr id="3" name="Rectangle 2"/>
-          <p:cNvSpPr/>
-          <p:nvPr/>
-        </p:nvSpPr>
-        <p:spPr>
-          <a:xfrm>
-            <a:off x="0" y="0"/>
-            <a:ext cx="73152" cy="6858000"/>
-          </a:xfrm>
-          <a:prstGeom prst="rect">
-            <a:avLst/>
-          </a:prstGeom>
-          <a:solidFill>
-            <a:srgbClr val="00B4D8"/>
-          </a:solidFill>
-          <a:ln>
-            <a:noFill/>
-          </a:ln>
-        </p:spPr>
-        <p:style>
-          <a:lnRef idx="1">
-            <a:schemeClr val="accent1"/>
-          </a:lnRef>
-          <a:fillRef idx="3">
-            <a:schemeClr val="accent1"/>
-          </a:fillRef>
-          <a:effectRef idx="2">
-            <a:schemeClr val="accent1"/>
-          </a:effectRef>
-          <a:fontRef idx="minor">
-            <a:schemeClr val="lt1"/>
-          </a:fontRef>
-        </p:style>
-        <p:txBody>
-          <a:bodyPr rtlCol="0" anchor="ctr"/>
-          <a:lstStyle/>
-          <a:p>
-            <a:pPr algn="ctr"/>
-          </a:p>
-        </p:txBody>
-      </p:sp>
-      <p:sp>
-        <p:nvSpPr>
-          <p:cNvPr id="4" name="TextBox 3"/>
-          <p:cNvSpPr txBox="1"/>
-          <p:nvPr/>
-        </p:nvSpPr>
-        <p:spPr>
-          <a:xfrm>
-            <a:off x="320040" y="256032"/>
-            <a:ext cx="11430000" cy="640080"/>
-          </a:xfrm>
-          <a:prstGeom prst="rect">
-            <a:avLst/>
-          </a:prstGeom>
-          <a:noFill/>
-        </p:spPr>
-        <p:txBody>
-          <a:bodyPr wrap="square">
-            <a:spAutoFit/>
-          </a:bodyPr>
-          <a:lstStyle/>
-          <a:p>
-            <a:pPr algn="l"/>
-            <a:r>
-              <a:rPr sz="3200" b="1" i="0">
-                <a:solidFill>
-                  <a:srgbClr val="00B4D8"/>
-                </a:solidFill>
-              </a:rPr>
-              <a:t>Summary &amp; Next Steps</a:t>
-            </a:r>
-          </a:p>
-        </p:txBody>
-      </p:sp>
-      <p:sp>
-        <p:nvSpPr>
-          <p:cNvPr id="5" name="TextBox 4"/>
-          <p:cNvSpPr txBox="1"/>
-          <p:nvPr/>
-        </p:nvSpPr>
-        <p:spPr>
-          <a:xfrm>
-            <a:off x="320040" y="868680"/>
-            <a:ext cx="11430000" cy="365760"/>
-          </a:xfrm>
-          <a:prstGeom prst="rect">
-            <a:avLst/>
-          </a:prstGeom>
-          <a:noFill/>
-        </p:spPr>
-        <p:txBody>
-          <a:bodyPr wrap="square">
-            <a:spAutoFit/>
-          </a:bodyPr>
-          <a:lstStyle/>
-          <a:p>
-            <a:pPr algn="l"/>
-            <a:r>
-              <a:rPr sz="1400" b="0" i="0">
-                <a:solidFill>
-                  <a:srgbClr val="94A3B8"/>
-                </a:solidFill>
-              </a:rPr>
-              <a:t>Where we go from here</a:t>
-            </a:r>
-          </a:p>
-        </p:txBody>
-      </p:sp>
-      <p:sp>
-        <p:nvSpPr>
-          <p:cNvPr id="6" name="Rectangle 5"/>
-          <p:cNvSpPr/>
-          <p:nvPr/>
-        </p:nvSpPr>
-        <p:spPr>
-          <a:xfrm>
-            <a:off x="320040" y="1417320"/>
-            <a:ext cx="5394960" cy="5120640"/>
-          </a:xfrm>
-          <a:prstGeom prst="rect">
-            <a:avLst/>
-          </a:prstGeom>
-          <a:solidFill>
-            <a:srgbClr val="162A40"/>
-          </a:solidFill>
-          <a:ln>
-            <a:noFill/>
-          </a:ln>
-        </p:spPr>
-        <p:style>
-          <a:lnRef idx="1">
-            <a:schemeClr val="accent1"/>
-          </a:lnRef>
-          <a:fillRef idx="3">
-            <a:schemeClr val="accent1"/>
-          </a:fillRef>
-          <a:effectRef idx="2">
-            <a:schemeClr val="accent1"/>
-          </a:effectRef>
-          <a:fontRef idx="minor">
-            <a:schemeClr val="lt1"/>
-          </a:fontRef>
-        </p:style>
-        <p:txBody>
-          <a:bodyPr rtlCol="0" anchor="ctr"/>
-          <a:lstStyle/>
-          <a:p>
-            <a:pPr algn="ctr"/>
-          </a:p>
-        </p:txBody>
-      </p:sp>
-      <p:sp>
-        <p:nvSpPr>
-          <p:cNvPr id="7" name="TextBox 6"/>
-          <p:cNvSpPr txBox="1"/>
-          <p:nvPr/>
-        </p:nvSpPr>
-        <p:spPr>
-          <a:xfrm>
-            <a:off x="502920" y="1508760"/>
-            <a:ext cx="5029200" cy="365760"/>
-          </a:xfrm>
-          <a:prstGeom prst="rect">
-            <a:avLst/>
-          </a:prstGeom>
-          <a:noFill/>
-        </p:spPr>
-        <p:txBody>
-          <a:bodyPr wrap="square">
-            <a:spAutoFit/>
-          </a:bodyPr>
-          <a:lstStyle/>
-          <a:p>
-            <a:pPr algn="l"/>
-            <a:r>
-              <a:rPr sz="1500" b="1" i="0">
-                <a:solidFill>
-                  <a:srgbClr val="00B4D8"/>
-                </a:solidFill>
-              </a:rPr>
-              <a:t>What We've Seen Today</a:t>
-            </a:r>
-          </a:p>
-        </p:txBody>
-      </p:sp>
-      <p:sp>
-        <p:nvSpPr>
-          <p:cNvPr id="8" name="TextBox 7"/>
-          <p:cNvSpPr txBox="1"/>
-          <p:nvPr/>
-        </p:nvSpPr>
-        <p:spPr>
-          <a:xfrm>
-            <a:off x="502920" y="1965960"/>
-            <a:ext cx="5029200" cy="274320"/>
-          </a:xfrm>
-          <a:prstGeom prst="rect">
-            <a:avLst/>
-          </a:prstGeom>
-          <a:noFill/>
-        </p:spPr>
-        <p:txBody>
-          <a:bodyPr wrap="square">
-            <a:spAutoFit/>
-          </a:bodyPr>
-          <a:lstStyle/>
-          <a:p>
-            <a:pPr algn="l"/>
-            <a:r>
-              <a:rPr sz="1100" b="0" i="0">
-                <a:solidFill>
-                  <a:srgbClr val="FFFFFF"/>
-                </a:solidFill>
-              </a:rPr>
-              <a:t>✓  Servallab automates end-to-end CATI QC</a:t>
-            </a:r>
-          </a:p>
-        </p:txBody>
-      </p:sp>
-      <p:sp>
-        <p:nvSpPr>
-          <p:cNvPr id="9" name="TextBox 8"/>
-          <p:cNvSpPr txBox="1"/>
-          <p:nvPr/>
-        </p:nvSpPr>
-        <p:spPr>
-          <a:xfrm>
-            <a:off x="502920" y="2514600"/>
-            <a:ext cx="5029200" cy="274320"/>
-          </a:xfrm>
-          <a:prstGeom prst="rect">
-            <a:avLst/>
-          </a:prstGeom>
-          <a:noFill/>
-        </p:spPr>
-        <p:txBody>
-          <a:bodyPr wrap="square">
-            <a:spAutoFit/>
-          </a:bodyPr>
-          <a:lstStyle/>
-          <a:p>
-            <a:pPr algn="l"/>
-            <a:r>
-              <a:rPr sz="1100" b="0" i="0">
-                <a:solidFill>
-                  <a:srgbClr val="FFFFFF"/>
-                </a:solidFill>
-              </a:rPr>
-              <a:t>✓  12+ checks covering fraud, logic, and data quality</a:t>
-            </a:r>
-          </a:p>
-        </p:txBody>
-      </p:sp>
-      <p:sp>
-        <p:nvSpPr>
-          <p:cNvPr id="10" name="TextBox 9"/>
-          <p:cNvSpPr txBox="1"/>
-          <p:nvPr/>
-        </p:nvSpPr>
-        <p:spPr>
-          <a:xfrm>
-            <a:off x="502920" y="3063240"/>
-            <a:ext cx="5029200" cy="274320"/>
-          </a:xfrm>
-          <a:prstGeom prst="rect">
-            <a:avLst/>
-          </a:prstGeom>
-          <a:noFill/>
-        </p:spPr>
-        <p:txBody>
-          <a:bodyPr wrap="square">
-            <a:spAutoFit/>
-          </a:bodyPr>
-          <a:lstStyle/>
-          <a:p>
-            <a:pPr algn="l"/>
-            <a:r>
-              <a:rPr sz="1100" b="0" i="0">
-                <a:solidFill>
-                  <a:srgbClr val="FFFFFF"/>
-                </a:solidFill>
-              </a:rPr>
-              <a:t>✓  AI-powered verbatim and rule-suggestion features</a:t>
-            </a:r>
-          </a:p>
-        </p:txBody>
-      </p:sp>
-      <p:sp>
-        <p:nvSpPr>
-          <p:cNvPr id="11" name="TextBox 10"/>
-          <p:cNvSpPr txBox="1"/>
-          <p:nvPr/>
-        </p:nvSpPr>
-        <p:spPr>
-          <a:xfrm>
-            <a:off x="502920" y="3611880"/>
-            <a:ext cx="5029200" cy="274320"/>
-          </a:xfrm>
-          <a:prstGeom prst="rect">
-            <a:avLst/>
-          </a:prstGeom>
-          <a:noFill/>
-        </p:spPr>
-        <p:txBody>
-          <a:bodyPr wrap="square">
-            <a:spAutoFit/>
-          </a:bodyPr>
-          <a:lstStyle/>
-          <a:p>
-            <a:pPr algn="l"/>
-            <a:r>
-              <a:rPr sz="1100" b="0" i="0">
-                <a:solidFill>
-                  <a:srgbClr val="FFFFFF"/>
-                </a:solidFill>
-              </a:rPr>
-              <a:t>✓  Interviewer risk profiling built in</a:t>
-            </a:r>
-          </a:p>
-        </p:txBody>
-      </p:sp>
-      <p:sp>
-        <p:nvSpPr>
-          <p:cNvPr id="12" name="TextBox 11"/>
-          <p:cNvSpPr txBox="1"/>
-          <p:nvPr/>
-        </p:nvSpPr>
-        <p:spPr>
-          <a:xfrm>
-            <a:off x="502920" y="4160520"/>
-            <a:ext cx="5029200" cy="274320"/>
-          </a:xfrm>
-          <a:prstGeom prst="rect">
-            <a:avLst/>
-          </a:prstGeom>
-          <a:noFill/>
-        </p:spPr>
-        <p:txBody>
-          <a:bodyPr wrap="square">
-            <a:spAutoFit/>
-          </a:bodyPr>
-          <a:lstStyle/>
-          <a:p>
-            <a:pPr algn="l"/>
-            <a:r>
-              <a:rPr sz="1100" b="0" i="0">
-                <a:solidFill>
-                  <a:srgbClr val="FFFFFF"/>
-                </a:solidFill>
-              </a:rPr>
-              <a:t>✓  Wave-over-wave longitudinal comparison</a:t>
-            </a:r>
-          </a:p>
-        </p:txBody>
-      </p:sp>
-      <p:sp>
-        <p:nvSpPr>
-          <p:cNvPr id="13" name="TextBox 12"/>
-          <p:cNvSpPr txBox="1"/>
-          <p:nvPr/>
-        </p:nvSpPr>
-        <p:spPr>
-          <a:xfrm>
-            <a:off x="502920" y="4709160"/>
-            <a:ext cx="5029200" cy="274320"/>
-          </a:xfrm>
-          <a:prstGeom prst="rect">
-            <a:avLst/>
-          </a:prstGeom>
-          <a:noFill/>
-        </p:spPr>
-        <p:txBody>
-          <a:bodyPr wrap="square">
-            <a:spAutoFit/>
-          </a:bodyPr>
-          <a:lstStyle/>
-          <a:p>
-            <a:pPr algn="l"/>
-            <a:r>
-              <a:rPr sz="1100" b="0" i="0">
-                <a:solidFill>
-                  <a:srgbClr val="FFFFFF"/>
-                </a:solidFill>
-              </a:rPr>
-              <a:t>✓  Fast, browser-based — no install required for analysts</a:t>
-            </a:r>
-          </a:p>
-        </p:txBody>
-      </p:sp>
-      <p:sp>
-        <p:nvSpPr>
-          <p:cNvPr id="14" name="TextBox 13"/>
-          <p:cNvSpPr txBox="1"/>
-          <p:nvPr/>
-        </p:nvSpPr>
-        <p:spPr>
-          <a:xfrm>
-            <a:off x="502920" y="5257800"/>
-            <a:ext cx="5029200" cy="274320"/>
-          </a:xfrm>
-          <a:prstGeom prst="rect">
-            <a:avLst/>
-          </a:prstGeom>
-          <a:noFill/>
-        </p:spPr>
-        <p:txBody>
-          <a:bodyPr wrap="square">
-            <a:spAutoFit/>
-          </a:bodyPr>
-          <a:lstStyle/>
-          <a:p>
-            <a:pPr algn="l"/>
-            <a:r>
-              <a:rPr sz="1100" b="0" i="0">
-                <a:solidFill>
-                  <a:srgbClr val="FFFFFF"/>
-                </a:solidFill>
-              </a:rPr>
-              <a:t>✓  Full audit trail and downloadable reports</a:t>
-            </a:r>
-          </a:p>
-        </p:txBody>
-      </p:sp>
-      <p:sp>
-        <p:nvSpPr>
-          <p:cNvPr id="15" name="TextBox 14"/>
-          <p:cNvSpPr txBox="1"/>
-          <p:nvPr/>
-        </p:nvSpPr>
-        <p:spPr>
-          <a:xfrm>
-            <a:off x="502920" y="5806440"/>
-            <a:ext cx="5029200" cy="274320"/>
-          </a:xfrm>
-          <a:prstGeom prst="rect">
-            <a:avLst/>
-          </a:prstGeom>
-          <a:noFill/>
-        </p:spPr>
-        <p:txBody>
-          <a:bodyPr wrap="square">
-            <a:spAutoFit/>
-          </a:bodyPr>
-          <a:lstStyle/>
-          <a:p>
-            <a:pPr algn="l"/>
-            <a:r>
-              <a:rPr sz="1100" b="0" i="0">
-                <a:solidFill>
-                  <a:srgbClr val="FFFFFF"/>
-                </a:solidFill>
-              </a:rPr>
-              <a:t>✓  Cloud-deployed, stateless, scales with your data volume</a:t>
-            </a:r>
-          </a:p>
-        </p:txBody>
-      </p:sp>
-      <p:sp>
-        <p:nvSpPr>
-          <p:cNvPr id="16" name="Rectangle 15"/>
-          <p:cNvSpPr/>
-          <p:nvPr/>
-        </p:nvSpPr>
-        <p:spPr>
-          <a:xfrm>
-            <a:off x="5989320" y="1417320"/>
-            <a:ext cx="5852160" cy="5120640"/>
-          </a:xfrm>
-          <a:prstGeom prst="rect">
-            <a:avLst/>
-          </a:prstGeom>
-          <a:solidFill>
-            <a:srgbClr val="162A40"/>
-          </a:solidFill>
-          <a:ln>
-            <a:noFill/>
-          </a:ln>
-        </p:spPr>
-        <p:style>
-          <a:lnRef idx="1">
-            <a:schemeClr val="accent1"/>
-          </a:lnRef>
-          <a:fillRef idx="3">
-            <a:schemeClr val="accent1"/>
-          </a:fillRef>
-          <a:effectRef idx="2">
-            <a:schemeClr val="accent1"/>
-          </a:effectRef>
-          <a:fontRef idx="minor">
-            <a:schemeClr val="lt1"/>
-          </a:fontRef>
-        </p:style>
-        <p:txBody>
-          <a:bodyPr rtlCol="0" anchor="ctr"/>
-          <a:lstStyle/>
-          <a:p>
-            <a:pPr algn="ctr"/>
-          </a:p>
-        </p:txBody>
-      </p:sp>
-      <p:sp>
-        <p:nvSpPr>
-          <p:cNvPr id="17" name="TextBox 16"/>
-          <p:cNvSpPr txBox="1"/>
-          <p:nvPr/>
-        </p:nvSpPr>
-        <p:spPr>
-          <a:xfrm>
-            <a:off x="6172200" y="1508760"/>
-            <a:ext cx="5486400" cy="365760"/>
-          </a:xfrm>
-          <a:prstGeom prst="rect">
-            <a:avLst/>
-          </a:prstGeom>
-          <a:noFill/>
-        </p:spPr>
-        <p:txBody>
-          <a:bodyPr wrap="square">
-            <a:spAutoFit/>
-          </a:bodyPr>
-          <a:lstStyle/>
-          <a:p>
-            <a:pPr algn="l"/>
-            <a:r>
-              <a:rPr sz="1500" b="1" i="0">
-                <a:solidFill>
-                  <a:srgbClr val="00B4D8"/>
-                </a:solidFill>
-              </a:rPr>
-              <a:t>Proposed Next Steps</a:t>
-            </a:r>
-          </a:p>
-        </p:txBody>
-      </p:sp>
-      <p:sp>
-        <p:nvSpPr>
-          <p:cNvPr id="18" name="Rectangle 17"/>
-          <p:cNvSpPr/>
-          <p:nvPr/>
-        </p:nvSpPr>
-        <p:spPr>
-          <a:xfrm>
-            <a:off x="6080760" y="1965960"/>
-            <a:ext cx="5577840" cy="822960"/>
-          </a:xfrm>
-          <a:prstGeom prst="rect">
-            <a:avLst/>
-          </a:prstGeom>
-          <a:solidFill>
-            <a:srgbClr val="0D1B2A"/>
-          </a:solidFill>
-          <a:ln>
-            <a:noFill/>
-          </a:ln>
-        </p:spPr>
-        <p:style>
-          <a:lnRef idx="1">
-            <a:schemeClr val="accent1"/>
-          </a:lnRef>
-          <a:fillRef idx="3">
-            <a:schemeClr val="accent1"/>
-          </a:fillRef>
-          <a:effectRef idx="2">
-            <a:schemeClr val="accent1"/>
-          </a:effectRef>
-          <a:fontRef idx="minor">
-            <a:schemeClr val="lt1"/>
-          </a:fontRef>
-        </p:style>
-        <p:txBody>
-          <a:bodyPr rtlCol="0" anchor="ctr"/>
-          <a:lstStyle/>
-          <a:p>
-            <a:pPr algn="ctr"/>
-          </a:p>
-        </p:txBody>
-      </p:sp>
-      <p:sp>
-        <p:nvSpPr>
-          <p:cNvPr id="19" name="TextBox 18"/>
-          <p:cNvSpPr txBox="1"/>
-          <p:nvPr/>
-        </p:nvSpPr>
-        <p:spPr>
-          <a:xfrm>
-            <a:off x="6172200" y="2011680"/>
-            <a:ext cx="1188720" cy="320040"/>
-          </a:xfrm>
-          <a:prstGeom prst="rect">
-            <a:avLst/>
-          </a:prstGeom>
-          <a:noFill/>
-        </p:spPr>
-        <p:txBody>
-          <a:bodyPr wrap="square">
-            <a:spAutoFit/>
-          </a:bodyPr>
-          <a:lstStyle/>
-          <a:p>
-            <a:pPr algn="l"/>
-            <a:r>
-              <a:rPr sz="1100" b="1" i="0">
-                <a:solidFill>
-                  <a:srgbClr val="00B4D8"/>
-                </a:solidFill>
-              </a:rPr>
-              <a:t>Week 1–2</a:t>
-            </a:r>
-          </a:p>
-        </p:txBody>
-      </p:sp>
-      <p:sp>
-        <p:nvSpPr>
-          <p:cNvPr id="20" name="TextBox 19"/>
-          <p:cNvSpPr txBox="1"/>
-          <p:nvPr/>
-        </p:nvSpPr>
-        <p:spPr>
-          <a:xfrm>
-            <a:off x="7452360" y="2011680"/>
-            <a:ext cx="4023360" cy="731520"/>
-          </a:xfrm>
-          <a:prstGeom prst="rect">
-            <a:avLst/>
-          </a:prstGeom>
-          <a:noFill/>
-        </p:spPr>
-        <p:txBody>
-          <a:bodyPr wrap="square">
-            <a:spAutoFit/>
-          </a:bodyPr>
-          <a:lstStyle/>
-          <a:p>
-            <a:pPr algn="l"/>
-            <a:r>
-              <a:rPr sz="1000" b="0" i="0">
-                <a:solidFill>
-                  <a:srgbClr val="FFFFFF"/>
-                </a:solidFill>
-              </a:rPr>
-              <a:t>Pilot with one active survey dataset — validate check outputs against known issues</a:t>
-            </a:r>
-          </a:p>
-        </p:txBody>
-      </p:sp>
-      <p:sp>
-        <p:nvSpPr>
-          <p:cNvPr id="21" name="Rectangle 20"/>
-          <p:cNvSpPr/>
-          <p:nvPr/>
-        </p:nvSpPr>
-        <p:spPr>
-          <a:xfrm>
-            <a:off x="6080760" y="2926080"/>
-            <a:ext cx="5577840" cy="822960"/>
-          </a:xfrm>
-          <a:prstGeom prst="rect">
-            <a:avLst/>
-          </a:prstGeom>
-          <a:solidFill>
-            <a:srgbClr val="0D1B2A"/>
-          </a:solidFill>
-          <a:ln>
-            <a:noFill/>
-          </a:ln>
-        </p:spPr>
-        <p:style>
-          <a:lnRef idx="1">
-            <a:schemeClr val="accent1"/>
-          </a:lnRef>
-          <a:fillRef idx="3">
-            <a:schemeClr val="accent1"/>
-          </a:fillRef>
-          <a:effectRef idx="2">
-            <a:schemeClr val="accent1"/>
-          </a:effectRef>
-          <a:fontRef idx="minor">
-            <a:schemeClr val="lt1"/>
-          </a:fontRef>
-        </p:style>
-        <p:txBody>
-          <a:bodyPr rtlCol="0" anchor="ctr"/>
-          <a:lstStyle/>
-          <a:p>
-            <a:pPr algn="ctr"/>
-          </a:p>
-        </p:txBody>
-      </p:sp>
-      <p:sp>
-        <p:nvSpPr>
-          <p:cNvPr id="22" name="TextBox 21"/>
-          <p:cNvSpPr txBox="1"/>
-          <p:nvPr/>
-        </p:nvSpPr>
-        <p:spPr>
-          <a:xfrm>
-            <a:off x="6172200" y="2971800"/>
-            <a:ext cx="1188720" cy="320040"/>
-          </a:xfrm>
-          <a:prstGeom prst="rect">
-            <a:avLst/>
-          </a:prstGeom>
-          <a:noFill/>
-        </p:spPr>
-        <p:txBody>
-          <a:bodyPr wrap="square">
-            <a:spAutoFit/>
-          </a:bodyPr>
-          <a:lstStyle/>
-          <a:p>
-            <a:pPr algn="l"/>
-            <a:r>
-              <a:rPr sz="1100" b="1" i="0">
-                <a:solidFill>
-                  <a:srgbClr val="00B4D8"/>
-                </a:solidFill>
-              </a:rPr>
-              <a:t>Week 3</a:t>
-            </a:r>
-          </a:p>
-        </p:txBody>
-      </p:sp>
-      <p:sp>
-        <p:nvSpPr>
-          <p:cNvPr id="23" name="TextBox 22"/>
-          <p:cNvSpPr txBox="1"/>
-          <p:nvPr/>
-        </p:nvSpPr>
-        <p:spPr>
-          <a:xfrm>
-            <a:off x="7452360" y="2971800"/>
-            <a:ext cx="4023360" cy="731520"/>
-          </a:xfrm>
-          <a:prstGeom prst="rect">
-            <a:avLst/>
-          </a:prstGeom>
-          <a:noFill/>
-        </p:spPr>
-        <p:txBody>
-          <a:bodyPr wrap="square">
-            <a:spAutoFit/>
-          </a:bodyPr>
-          <a:lstStyle/>
-          <a:p>
-            <a:pPr algn="l"/>
-            <a:r>
-              <a:rPr sz="1000" b="0" i="0">
-                <a:solidFill>
-                  <a:srgbClr val="FFFFFF"/>
-                </a:solidFill>
-              </a:rPr>
-              <a:t>Analyst training session — live walkthrough of all 10 tabs and rule configuration</a:t>
-            </a:r>
-          </a:p>
-        </p:txBody>
-      </p:sp>
-      <p:sp>
-        <p:nvSpPr>
-          <p:cNvPr id="24" name="Rectangle 23"/>
-          <p:cNvSpPr/>
-          <p:nvPr/>
-        </p:nvSpPr>
-        <p:spPr>
-          <a:xfrm>
-            <a:off x="6080760" y="3886200"/>
-            <a:ext cx="5577840" cy="822960"/>
-          </a:xfrm>
-          <a:prstGeom prst="rect">
-            <a:avLst/>
-          </a:prstGeom>
-          <a:solidFill>
-            <a:srgbClr val="0D1B2A"/>
-          </a:solidFill>
-          <a:ln>
-            <a:noFill/>
-          </a:ln>
-        </p:spPr>
-        <p:style>
-          <a:lnRef idx="1">
-            <a:schemeClr val="accent1"/>
-          </a:lnRef>
-          <a:fillRef idx="3">
-            <a:schemeClr val="accent1"/>
-          </a:fillRef>
-          <a:effectRef idx="2">
-            <a:schemeClr val="accent1"/>
-          </a:effectRef>
-          <a:fontRef idx="minor">
-            <a:schemeClr val="lt1"/>
-          </a:fontRef>
-        </p:style>
-        <p:txBody>
-          <a:bodyPr rtlCol="0" anchor="ctr"/>
-          <a:lstStyle/>
-          <a:p>
-            <a:pPr algn="ctr"/>
-          </a:p>
-        </p:txBody>
-      </p:sp>
-      <p:sp>
-        <p:nvSpPr>
-          <p:cNvPr id="25" name="TextBox 24"/>
-          <p:cNvSpPr txBox="1"/>
-          <p:nvPr/>
-        </p:nvSpPr>
-        <p:spPr>
-          <a:xfrm>
-            <a:off x="6172200" y="3931920"/>
-            <a:ext cx="1188720" cy="320040"/>
-          </a:xfrm>
-          <a:prstGeom prst="rect">
-            <a:avLst/>
-          </a:prstGeom>
-          <a:noFill/>
-        </p:spPr>
-        <p:txBody>
-          <a:bodyPr wrap="square">
-            <a:spAutoFit/>
-          </a:bodyPr>
-          <a:lstStyle/>
-          <a:p>
-            <a:pPr algn="l"/>
-            <a:r>
-              <a:rPr sz="1100" b="1" i="0">
-                <a:solidFill>
-                  <a:srgbClr val="00B4D8"/>
-                </a:solidFill>
-              </a:rPr>
-              <a:t>Week 4</a:t>
-            </a:r>
-          </a:p>
-        </p:txBody>
-      </p:sp>
-      <p:sp>
-        <p:nvSpPr>
-          <p:cNvPr id="26" name="TextBox 25"/>
-          <p:cNvSpPr txBox="1"/>
-          <p:nvPr/>
-        </p:nvSpPr>
-        <p:spPr>
-          <a:xfrm>
-            <a:off x="7452360" y="3931920"/>
-            <a:ext cx="4023360" cy="731520"/>
-          </a:xfrm>
-          <a:prstGeom prst="rect">
-            <a:avLst/>
-          </a:prstGeom>
-          <a:noFill/>
-        </p:spPr>
-        <p:txBody>
-          <a:bodyPr wrap="square">
-            <a:spAutoFit/>
-          </a:bodyPr>
-          <a:lstStyle/>
-          <a:p>
-            <a:pPr algn="l"/>
-            <a:r>
-              <a:rPr sz="1000" b="0" i="0">
-                <a:solidFill>
-                  <a:srgbClr val="FFFFFF"/>
-                </a:solidFill>
-              </a:rPr>
-              <a:t>Customise logic rules and thresholds for your specific survey instruments</a:t>
-            </a:r>
-          </a:p>
-        </p:txBody>
-      </p:sp>
-      <p:sp>
-        <p:nvSpPr>
-          <p:cNvPr id="27" name="Rectangle 26"/>
-          <p:cNvSpPr/>
-          <p:nvPr/>
-        </p:nvSpPr>
-        <p:spPr>
-          <a:xfrm>
-            <a:off x="6080760" y="4846320"/>
-            <a:ext cx="5577840" cy="822960"/>
-          </a:xfrm>
-          <a:prstGeom prst="rect">
-            <a:avLst/>
-          </a:prstGeom>
-          <a:solidFill>
-            <a:srgbClr val="0D1B2A"/>
-          </a:solidFill>
-          <a:ln>
-            <a:noFill/>
-          </a:ln>
-        </p:spPr>
-        <p:style>
-          <a:lnRef idx="1">
-            <a:schemeClr val="accent1"/>
-          </a:lnRef>
-          <a:fillRef idx="3">
-            <a:schemeClr val="accent1"/>
-          </a:fillRef>
-          <a:effectRef idx="2">
-            <a:schemeClr val="accent1"/>
-          </a:effectRef>
-          <a:fontRef idx="minor">
-            <a:schemeClr val="lt1"/>
-          </a:fontRef>
-        </p:style>
-        <p:txBody>
-          <a:bodyPr rtlCol="0" anchor="ctr"/>
-          <a:lstStyle/>
-          <a:p>
-            <a:pPr algn="ctr"/>
-          </a:p>
-        </p:txBody>
-      </p:sp>
-      <p:sp>
-        <p:nvSpPr>
-          <p:cNvPr id="28" name="TextBox 27"/>
-          <p:cNvSpPr txBox="1"/>
-          <p:nvPr/>
-        </p:nvSpPr>
-        <p:spPr>
-          <a:xfrm>
-            <a:off x="6172200" y="4892040"/>
-            <a:ext cx="1188720" cy="320040"/>
-          </a:xfrm>
-          <a:prstGeom prst="rect">
-            <a:avLst/>
-          </a:prstGeom>
-          <a:noFill/>
-        </p:spPr>
-        <p:txBody>
-          <a:bodyPr wrap="square">
-            <a:spAutoFit/>
-          </a:bodyPr>
-          <a:lstStyle/>
-          <a:p>
-            <a:pPr algn="l"/>
-            <a:r>
-              <a:rPr sz="1100" b="1" i="0">
-                <a:solidFill>
-                  <a:srgbClr val="00B4D8"/>
-                </a:solidFill>
-              </a:rPr>
-              <a:t>Month 2</a:t>
-            </a:r>
-          </a:p>
-        </p:txBody>
-      </p:sp>
-      <p:sp>
-        <p:nvSpPr>
-          <p:cNvPr id="29" name="TextBox 28"/>
-          <p:cNvSpPr txBox="1"/>
-          <p:nvPr/>
-        </p:nvSpPr>
-        <p:spPr>
-          <a:xfrm>
-            <a:off x="7452360" y="4892040"/>
-            <a:ext cx="4023360" cy="731520"/>
-          </a:xfrm>
-          <a:prstGeom prst="rect">
-            <a:avLst/>
-          </a:prstGeom>
-          <a:noFill/>
-        </p:spPr>
-        <p:txBody>
-          <a:bodyPr wrap="square">
-            <a:spAutoFit/>
-          </a:bodyPr>
-          <a:lstStyle/>
-          <a:p>
-            <a:pPr algn="l"/>
-            <a:r>
-              <a:rPr sz="1000" b="0" i="0">
-                <a:solidFill>
-                  <a:srgbClr val="FFFFFF"/>
-                </a:solidFill>
-              </a:rPr>
-              <a:t>Roll out to full ops team — integrate QC sign-off into fieldwork SOP</a:t>
-            </a:r>
-          </a:p>
-        </p:txBody>
-      </p:sp>
-      <p:sp>
-        <p:nvSpPr>
-          <p:cNvPr id="30" name="Rectangle 29"/>
-          <p:cNvSpPr/>
-          <p:nvPr/>
-        </p:nvSpPr>
-        <p:spPr>
-          <a:xfrm>
-            <a:off x="6080760" y="5806440"/>
-            <a:ext cx="5577840" cy="822960"/>
-          </a:xfrm>
-          <a:prstGeom prst="rect">
-            <a:avLst/>
-          </a:prstGeom>
-          <a:solidFill>
-            <a:srgbClr val="0D1B2A"/>
-          </a:solidFill>
-          <a:ln>
-            <a:noFill/>
-          </a:ln>
-        </p:spPr>
-        <p:style>
-          <a:lnRef idx="1">
-            <a:schemeClr val="accent1"/>
-          </a:lnRef>
-          <a:fillRef idx="3">
-            <a:schemeClr val="accent1"/>
-          </a:fillRef>
-          <a:effectRef idx="2">
-            <a:schemeClr val="accent1"/>
-          </a:effectRef>
-          <a:fontRef idx="minor">
-            <a:schemeClr val="lt1"/>
-          </a:fontRef>
-        </p:style>
-        <p:txBody>
-          <a:bodyPr rtlCol="0" anchor="ctr"/>
-          <a:lstStyle/>
-          <a:p>
-            <a:pPr algn="ctr"/>
-          </a:p>
-        </p:txBody>
-      </p:sp>
-      <p:sp>
-        <p:nvSpPr>
-          <p:cNvPr id="31" name="TextBox 30"/>
-          <p:cNvSpPr txBox="1"/>
-          <p:nvPr/>
-        </p:nvSpPr>
-        <p:spPr>
-          <a:xfrm>
-            <a:off x="6172200" y="5852160"/>
-            <a:ext cx="1188720" cy="320040"/>
-          </a:xfrm>
-          <a:prstGeom prst="rect">
-            <a:avLst/>
-          </a:prstGeom>
-          <a:noFill/>
-        </p:spPr>
-        <p:txBody>
-          <a:bodyPr wrap="square">
-            <a:spAutoFit/>
-          </a:bodyPr>
-          <a:lstStyle/>
-          <a:p>
-            <a:pPr algn="l"/>
-            <a:r>
-              <a:rPr sz="1100" b="1" i="0">
-                <a:solidFill>
-                  <a:srgbClr val="00B4D8"/>
-                </a:solidFill>
-              </a:rPr>
-              <a:t>Ongoing</a:t>
-            </a:r>
-          </a:p>
-        </p:txBody>
-      </p:sp>
-      <p:sp>
-        <p:nvSpPr>
-          <p:cNvPr id="32" name="TextBox 31"/>
-          <p:cNvSpPr txBox="1"/>
-          <p:nvPr/>
-        </p:nvSpPr>
-        <p:spPr>
-          <a:xfrm>
-            <a:off x="7452360" y="5852160"/>
-            <a:ext cx="4023360" cy="731520"/>
-          </a:xfrm>
-          <a:prstGeom prst="rect">
-            <a:avLst/>
-          </a:prstGeom>
-          <a:noFill/>
-        </p:spPr>
-        <p:txBody>
-          <a:bodyPr wrap="square">
-            <a:spAutoFit/>
-          </a:bodyPr>
-          <a:lstStyle/>
-          <a:p>
-            <a:pPr algn="l"/>
-            <a:r>
-              <a:rPr sz="1000" b="0" i="0">
-                <a:solidFill>
-                  <a:srgbClr val="FFFFFF"/>
-                </a:solidFill>
-              </a:rPr>
-              <a:t>AI rule suggestions reviewed quarterly; new check modules added per roadmap</a:t>
-            </a:r>
-          </a:p>
-        </p:txBody>
-      </p:sp>
-    </p:spTree>
-  </p:cSld>
-  <p:clrMapOvr>
-    <a:masterClrMapping/>
-  </p:clrMapOvr>
-</p:sld>
-</file>
-
 <file path=ppt/slides/slide11.xml><?xml version="1.0" encoding="utf-8"?>
 <p:sld xmlns:a="http://schemas.openxmlformats.org/drawingml/2006/main" xmlns:p="http://schemas.openxmlformats.org/presentationml/2006/main" xmlns:r="http://schemas.openxmlformats.org/officeDocument/2006/relationships">
   <p:cSld>
@@ -4949,1048 +3793,6 @@
                 </a:solidFill>
               </a:rPr>
               <a:t>Live:    servalab.com</a:t>
-            </a:r>
-          </a:p>
-        </p:txBody>
-      </p:sp>
-    </p:spTree>
-  </p:cSld>
-  <p:clrMapOvr>
-    <a:masterClrMapping/>
-  </p:clrMapOvr>
-</p:sld>
-</file>
-
-<file path=ppt/slides/slide2.xml><?xml version="1.0" encoding="utf-8"?>
-<p:sld xmlns:a="http://schemas.openxmlformats.org/drawingml/2006/main" xmlns:p="http://schemas.openxmlformats.org/presentationml/2006/main" xmlns:r="http://schemas.openxmlformats.org/officeDocument/2006/relationships">
-  <p:cSld>
-    <p:spTree>
-      <p:nvGrpSpPr>
-        <p:cNvPr id="1" name=""/>
-        <p:cNvGrpSpPr/>
-        <p:nvPr/>
-      </p:nvGrpSpPr>
-      <p:grpSpPr/>
-      <p:sp>
-        <p:nvSpPr>
-          <p:cNvPr id="2" name="Rectangle 1"/>
-          <p:cNvSpPr/>
-          <p:nvPr/>
-        </p:nvSpPr>
-        <p:spPr>
-          <a:xfrm>
-            <a:off x="0" y="0"/>
-            <a:ext cx="12188952" cy="6858000"/>
-          </a:xfrm>
-          <a:prstGeom prst="rect">
-            <a:avLst/>
-          </a:prstGeom>
-          <a:solidFill>
-            <a:srgbClr val="0D1B2A"/>
-          </a:solidFill>
-          <a:ln>
-            <a:noFill/>
-          </a:ln>
-        </p:spPr>
-        <p:style>
-          <a:lnRef idx="1">
-            <a:schemeClr val="accent1"/>
-          </a:lnRef>
-          <a:fillRef idx="3">
-            <a:schemeClr val="accent1"/>
-          </a:fillRef>
-          <a:effectRef idx="2">
-            <a:schemeClr val="accent1"/>
-          </a:effectRef>
-          <a:fontRef idx="minor">
-            <a:schemeClr val="lt1"/>
-          </a:fontRef>
-        </p:style>
-        <p:txBody>
-          <a:bodyPr rtlCol="0" anchor="ctr"/>
-          <a:lstStyle/>
-          <a:p>
-            <a:pPr algn="ctr"/>
-          </a:p>
-        </p:txBody>
-      </p:sp>
-      <p:sp>
-        <p:nvSpPr>
-          <p:cNvPr id="3" name="Rectangle 2"/>
-          <p:cNvSpPr/>
-          <p:nvPr/>
-        </p:nvSpPr>
-        <p:spPr>
-          <a:xfrm>
-            <a:off x="0" y="0"/>
-            <a:ext cx="73152" cy="6858000"/>
-          </a:xfrm>
-          <a:prstGeom prst="rect">
-            <a:avLst/>
-          </a:prstGeom>
-          <a:solidFill>
-            <a:srgbClr val="00B4D8"/>
-          </a:solidFill>
-          <a:ln>
-            <a:noFill/>
-          </a:ln>
-        </p:spPr>
-        <p:style>
-          <a:lnRef idx="1">
-            <a:schemeClr val="accent1"/>
-          </a:lnRef>
-          <a:fillRef idx="3">
-            <a:schemeClr val="accent1"/>
-          </a:fillRef>
-          <a:effectRef idx="2">
-            <a:schemeClr val="accent1"/>
-          </a:effectRef>
-          <a:fontRef idx="minor">
-            <a:schemeClr val="lt1"/>
-          </a:fontRef>
-        </p:style>
-        <p:txBody>
-          <a:bodyPr rtlCol="0" anchor="ctr"/>
-          <a:lstStyle/>
-          <a:p>
-            <a:pPr algn="ctr"/>
-          </a:p>
-        </p:txBody>
-      </p:sp>
-      <p:sp>
-        <p:nvSpPr>
-          <p:cNvPr id="4" name="TextBox 3"/>
-          <p:cNvSpPr txBox="1"/>
-          <p:nvPr/>
-        </p:nvSpPr>
-        <p:spPr>
-          <a:xfrm>
-            <a:off x="320040" y="256032"/>
-            <a:ext cx="11430000" cy="640080"/>
-          </a:xfrm>
-          <a:prstGeom prst="rect">
-            <a:avLst/>
-          </a:prstGeom>
-          <a:noFill/>
-        </p:spPr>
-        <p:txBody>
-          <a:bodyPr wrap="square">
-            <a:spAutoFit/>
-          </a:bodyPr>
-          <a:lstStyle/>
-          <a:p>
-            <a:pPr algn="l"/>
-            <a:r>
-              <a:rPr sz="3200" b="1" i="0">
-                <a:solidFill>
-                  <a:srgbClr val="00B4D8"/>
-                </a:solidFill>
-              </a:rPr>
-              <a:t>Agenda</a:t>
-            </a:r>
-          </a:p>
-        </p:txBody>
-      </p:sp>
-      <p:sp>
-        <p:nvSpPr>
-          <p:cNvPr id="5" name="TextBox 4"/>
-          <p:cNvSpPr txBox="1"/>
-          <p:nvPr/>
-        </p:nvSpPr>
-        <p:spPr>
-          <a:xfrm>
-            <a:off x="320040" y="868680"/>
-            <a:ext cx="11430000" cy="365760"/>
-          </a:xfrm>
-          <a:prstGeom prst="rect">
-            <a:avLst/>
-          </a:prstGeom>
-          <a:noFill/>
-        </p:spPr>
-        <p:txBody>
-          <a:bodyPr wrap="square">
-            <a:spAutoFit/>
-          </a:bodyPr>
-          <a:lstStyle/>
-          <a:p>
-            <a:pPr algn="l"/>
-            <a:r>
-              <a:rPr sz="1400" b="0" i="0">
-                <a:solidFill>
-                  <a:srgbClr val="94A3B8"/>
-                </a:solidFill>
-              </a:rPr>
-              <a:t>What we'll cover today</a:t>
-            </a:r>
-          </a:p>
-        </p:txBody>
-      </p:sp>
-      <p:sp>
-        <p:nvSpPr>
-          <p:cNvPr id="6" name="Rectangle 5"/>
-          <p:cNvSpPr/>
-          <p:nvPr/>
-        </p:nvSpPr>
-        <p:spPr>
-          <a:xfrm>
-            <a:off x="365760" y="1371600"/>
-            <a:ext cx="5577840" cy="1234440"/>
-          </a:xfrm>
-          <a:prstGeom prst="rect">
-            <a:avLst/>
-          </a:prstGeom>
-          <a:solidFill>
-            <a:srgbClr val="162A40"/>
-          </a:solidFill>
-          <a:ln>
-            <a:noFill/>
-          </a:ln>
-        </p:spPr>
-        <p:style>
-          <a:lnRef idx="1">
-            <a:schemeClr val="accent1"/>
-          </a:lnRef>
-          <a:fillRef idx="3">
-            <a:schemeClr val="accent1"/>
-          </a:fillRef>
-          <a:effectRef idx="2">
-            <a:schemeClr val="accent1"/>
-          </a:effectRef>
-          <a:fontRef idx="minor">
-            <a:schemeClr val="lt1"/>
-          </a:fontRef>
-        </p:style>
-        <p:txBody>
-          <a:bodyPr rtlCol="0" anchor="ctr"/>
-          <a:lstStyle/>
-          <a:p>
-            <a:pPr algn="ctr"/>
-          </a:p>
-        </p:txBody>
-      </p:sp>
-      <p:sp>
-        <p:nvSpPr>
-          <p:cNvPr id="7" name="TextBox 6"/>
-          <p:cNvSpPr txBox="1"/>
-          <p:nvPr/>
-        </p:nvSpPr>
-        <p:spPr>
-          <a:xfrm>
-            <a:off x="548640" y="1508760"/>
-            <a:ext cx="731520" cy="594360"/>
-          </a:xfrm>
-          <a:prstGeom prst="rect">
-            <a:avLst/>
-          </a:prstGeom>
-          <a:noFill/>
-        </p:spPr>
-        <p:txBody>
-          <a:bodyPr wrap="square">
-            <a:spAutoFit/>
-          </a:bodyPr>
-          <a:lstStyle/>
-          <a:p>
-            <a:pPr algn="l"/>
-            <a:r>
-              <a:rPr sz="2800" b="1" i="0">
-                <a:solidFill>
-                  <a:srgbClr val="00B4D8"/>
-                </a:solidFill>
-              </a:rPr>
-              <a:t>01</a:t>
-            </a:r>
-          </a:p>
-        </p:txBody>
-      </p:sp>
-      <p:sp>
-        <p:nvSpPr>
-          <p:cNvPr id="8" name="TextBox 7"/>
-          <p:cNvSpPr txBox="1"/>
-          <p:nvPr/>
-        </p:nvSpPr>
-        <p:spPr>
-          <a:xfrm>
-            <a:off x="1280160" y="1508760"/>
-            <a:ext cx="4389120" cy="411480"/>
-          </a:xfrm>
-          <a:prstGeom prst="rect">
-            <a:avLst/>
-          </a:prstGeom>
-          <a:noFill/>
-        </p:spPr>
-        <p:txBody>
-          <a:bodyPr wrap="square">
-            <a:spAutoFit/>
-          </a:bodyPr>
-          <a:lstStyle/>
-          <a:p>
-            <a:pPr algn="l"/>
-            <a:r>
-              <a:rPr sz="1500" b="1" i="0">
-                <a:solidFill>
-                  <a:srgbClr val="FFFFFF"/>
-                </a:solidFill>
-              </a:rPr>
-              <a:t>What is Servallab?</a:t>
-            </a:r>
-          </a:p>
-        </p:txBody>
-      </p:sp>
-      <p:sp>
-        <p:nvSpPr>
-          <p:cNvPr id="9" name="TextBox 8"/>
-          <p:cNvSpPr txBox="1"/>
-          <p:nvPr/>
-        </p:nvSpPr>
-        <p:spPr>
-          <a:xfrm>
-            <a:off x="1280160" y="1920240"/>
-            <a:ext cx="4389120" cy="502920"/>
-          </a:xfrm>
-          <a:prstGeom prst="rect">
-            <a:avLst/>
-          </a:prstGeom>
-          <a:noFill/>
-        </p:spPr>
-        <p:txBody>
-          <a:bodyPr wrap="square">
-            <a:spAutoFit/>
-          </a:bodyPr>
-          <a:lstStyle/>
-          <a:p>
-            <a:pPr algn="l"/>
-            <a:r>
-              <a:rPr sz="1100" b="0" i="0">
-                <a:solidFill>
-                  <a:srgbClr val="94A3B8"/>
-                </a:solidFill>
-              </a:rPr>
-              <a:t>Project overview &amp; the problem it solves</a:t>
-            </a:r>
-          </a:p>
-        </p:txBody>
-      </p:sp>
-      <p:sp>
-        <p:nvSpPr>
-          <p:cNvPr id="10" name="Rectangle 9"/>
-          <p:cNvSpPr/>
-          <p:nvPr/>
-        </p:nvSpPr>
-        <p:spPr>
-          <a:xfrm>
-            <a:off x="6217920" y="1371600"/>
-            <a:ext cx="5577840" cy="1234440"/>
-          </a:xfrm>
-          <a:prstGeom prst="rect">
-            <a:avLst/>
-          </a:prstGeom>
-          <a:solidFill>
-            <a:srgbClr val="162A40"/>
-          </a:solidFill>
-          <a:ln>
-            <a:noFill/>
-          </a:ln>
-        </p:spPr>
-        <p:style>
-          <a:lnRef idx="1">
-            <a:schemeClr val="accent1"/>
-          </a:lnRef>
-          <a:fillRef idx="3">
-            <a:schemeClr val="accent1"/>
-          </a:fillRef>
-          <a:effectRef idx="2">
-            <a:schemeClr val="accent1"/>
-          </a:effectRef>
-          <a:fontRef idx="minor">
-            <a:schemeClr val="lt1"/>
-          </a:fontRef>
-        </p:style>
-        <p:txBody>
-          <a:bodyPr rtlCol="0" anchor="ctr"/>
-          <a:lstStyle/>
-          <a:p>
-            <a:pPr algn="ctr"/>
-          </a:p>
-        </p:txBody>
-      </p:sp>
-      <p:sp>
-        <p:nvSpPr>
-          <p:cNvPr id="11" name="TextBox 10"/>
-          <p:cNvSpPr txBox="1"/>
-          <p:nvPr/>
-        </p:nvSpPr>
-        <p:spPr>
-          <a:xfrm>
-            <a:off x="6400800" y="1508760"/>
-            <a:ext cx="731520" cy="594360"/>
-          </a:xfrm>
-          <a:prstGeom prst="rect">
-            <a:avLst/>
-          </a:prstGeom>
-          <a:noFill/>
-        </p:spPr>
-        <p:txBody>
-          <a:bodyPr wrap="square">
-            <a:spAutoFit/>
-          </a:bodyPr>
-          <a:lstStyle/>
-          <a:p>
-            <a:pPr algn="l"/>
-            <a:r>
-              <a:rPr sz="2800" b="1" i="0">
-                <a:solidFill>
-                  <a:srgbClr val="00B4D8"/>
-                </a:solidFill>
-              </a:rPr>
-              <a:t>02</a:t>
-            </a:r>
-          </a:p>
-        </p:txBody>
-      </p:sp>
-      <p:sp>
-        <p:nvSpPr>
-          <p:cNvPr id="12" name="TextBox 11"/>
-          <p:cNvSpPr txBox="1"/>
-          <p:nvPr/>
-        </p:nvSpPr>
-        <p:spPr>
-          <a:xfrm>
-            <a:off x="7132320" y="1508760"/>
-            <a:ext cx="4389120" cy="411480"/>
-          </a:xfrm>
-          <a:prstGeom prst="rect">
-            <a:avLst/>
-          </a:prstGeom>
-          <a:noFill/>
-        </p:spPr>
-        <p:txBody>
-          <a:bodyPr wrap="square">
-            <a:spAutoFit/>
-          </a:bodyPr>
-          <a:lstStyle/>
-          <a:p>
-            <a:pPr algn="l"/>
-            <a:r>
-              <a:rPr sz="1500" b="1" i="0">
-                <a:solidFill>
-                  <a:srgbClr val="FFFFFF"/>
-                </a:solidFill>
-              </a:rPr>
-              <a:t>Business Benefits</a:t>
-            </a:r>
-          </a:p>
-        </p:txBody>
-      </p:sp>
-      <p:sp>
-        <p:nvSpPr>
-          <p:cNvPr id="13" name="TextBox 12"/>
-          <p:cNvSpPr txBox="1"/>
-          <p:nvPr/>
-        </p:nvSpPr>
-        <p:spPr>
-          <a:xfrm>
-            <a:off x="7132320" y="1920240"/>
-            <a:ext cx="4389120" cy="502920"/>
-          </a:xfrm>
-          <a:prstGeom prst="rect">
-            <a:avLst/>
-          </a:prstGeom>
-          <a:noFill/>
-        </p:spPr>
-        <p:txBody>
-          <a:bodyPr wrap="square">
-            <a:spAutoFit/>
-          </a:bodyPr>
-          <a:lstStyle/>
-          <a:p>
-            <a:pPr algn="l"/>
-            <a:r>
-              <a:rPr sz="1100" b="0" i="0">
-                <a:solidFill>
-                  <a:srgbClr val="94A3B8"/>
-                </a:solidFill>
-              </a:rPr>
-              <a:t>ROI, risk reduction &amp; operational wins</a:t>
-            </a:r>
-          </a:p>
-        </p:txBody>
-      </p:sp>
-      <p:sp>
-        <p:nvSpPr>
-          <p:cNvPr id="14" name="Rectangle 13"/>
-          <p:cNvSpPr/>
-          <p:nvPr/>
-        </p:nvSpPr>
-        <p:spPr>
-          <a:xfrm>
-            <a:off x="365760" y="2834640"/>
-            <a:ext cx="5577840" cy="1234440"/>
-          </a:xfrm>
-          <a:prstGeom prst="rect">
-            <a:avLst/>
-          </a:prstGeom>
-          <a:solidFill>
-            <a:srgbClr val="162A40"/>
-          </a:solidFill>
-          <a:ln>
-            <a:noFill/>
-          </a:ln>
-        </p:spPr>
-        <p:style>
-          <a:lnRef idx="1">
-            <a:schemeClr val="accent1"/>
-          </a:lnRef>
-          <a:fillRef idx="3">
-            <a:schemeClr val="accent1"/>
-          </a:fillRef>
-          <a:effectRef idx="2">
-            <a:schemeClr val="accent1"/>
-          </a:effectRef>
-          <a:fontRef idx="minor">
-            <a:schemeClr val="lt1"/>
-          </a:fontRef>
-        </p:style>
-        <p:txBody>
-          <a:bodyPr rtlCol="0" anchor="ctr"/>
-          <a:lstStyle/>
-          <a:p>
-            <a:pPr algn="ctr"/>
-          </a:p>
-        </p:txBody>
-      </p:sp>
-      <p:sp>
-        <p:nvSpPr>
-          <p:cNvPr id="15" name="TextBox 14"/>
-          <p:cNvSpPr txBox="1"/>
-          <p:nvPr/>
-        </p:nvSpPr>
-        <p:spPr>
-          <a:xfrm>
-            <a:off x="548640" y="2971800"/>
-            <a:ext cx="731520" cy="594360"/>
-          </a:xfrm>
-          <a:prstGeom prst="rect">
-            <a:avLst/>
-          </a:prstGeom>
-          <a:noFill/>
-        </p:spPr>
-        <p:txBody>
-          <a:bodyPr wrap="square">
-            <a:spAutoFit/>
-          </a:bodyPr>
-          <a:lstStyle/>
-          <a:p>
-            <a:pPr algn="l"/>
-            <a:r>
-              <a:rPr sz="2800" b="1" i="0">
-                <a:solidFill>
-                  <a:srgbClr val="00B4D8"/>
-                </a:solidFill>
-              </a:rPr>
-              <a:t>03</a:t>
-            </a:r>
-          </a:p>
-        </p:txBody>
-      </p:sp>
-      <p:sp>
-        <p:nvSpPr>
-          <p:cNvPr id="16" name="TextBox 15"/>
-          <p:cNvSpPr txBox="1"/>
-          <p:nvPr/>
-        </p:nvSpPr>
-        <p:spPr>
-          <a:xfrm>
-            <a:off x="1280160" y="2971800"/>
-            <a:ext cx="4389120" cy="411480"/>
-          </a:xfrm>
-          <a:prstGeom prst="rect">
-            <a:avLst/>
-          </a:prstGeom>
-          <a:noFill/>
-        </p:spPr>
-        <p:txBody>
-          <a:bodyPr wrap="square">
-            <a:spAutoFit/>
-          </a:bodyPr>
-          <a:lstStyle/>
-          <a:p>
-            <a:pPr algn="l"/>
-            <a:r>
-              <a:rPr sz="1500" b="1" i="0">
-                <a:solidFill>
-                  <a:srgbClr val="FFFFFF"/>
-                </a:solidFill>
-              </a:rPr>
-              <a:t>How to Use Servallab</a:t>
-            </a:r>
-          </a:p>
-        </p:txBody>
-      </p:sp>
-      <p:sp>
-        <p:nvSpPr>
-          <p:cNvPr id="17" name="TextBox 16"/>
-          <p:cNvSpPr txBox="1"/>
-          <p:nvPr/>
-        </p:nvSpPr>
-        <p:spPr>
-          <a:xfrm>
-            <a:off x="1280160" y="3383280"/>
-            <a:ext cx="4389120" cy="502920"/>
-          </a:xfrm>
-          <a:prstGeom prst="rect">
-            <a:avLst/>
-          </a:prstGeom>
-          <a:noFill/>
-        </p:spPr>
-        <p:txBody>
-          <a:bodyPr wrap="square">
-            <a:spAutoFit/>
-          </a:bodyPr>
-          <a:lstStyle/>
-          <a:p>
-            <a:pPr algn="l"/>
-            <a:r>
-              <a:rPr sz="1100" b="0" i="0">
-                <a:solidFill>
-                  <a:srgbClr val="94A3B8"/>
-                </a:solidFill>
-              </a:rPr>
-              <a:t>Step-by-step user guide</a:t>
-            </a:r>
-          </a:p>
-        </p:txBody>
-      </p:sp>
-      <p:sp>
-        <p:nvSpPr>
-          <p:cNvPr id="18" name="Rectangle 17"/>
-          <p:cNvSpPr/>
-          <p:nvPr/>
-        </p:nvSpPr>
-        <p:spPr>
-          <a:xfrm>
-            <a:off x="6217920" y="2834640"/>
-            <a:ext cx="5577840" cy="1234440"/>
-          </a:xfrm>
-          <a:prstGeom prst="rect">
-            <a:avLst/>
-          </a:prstGeom>
-          <a:solidFill>
-            <a:srgbClr val="162A40"/>
-          </a:solidFill>
-          <a:ln>
-            <a:noFill/>
-          </a:ln>
-        </p:spPr>
-        <p:style>
-          <a:lnRef idx="1">
-            <a:schemeClr val="accent1"/>
-          </a:lnRef>
-          <a:fillRef idx="3">
-            <a:schemeClr val="accent1"/>
-          </a:fillRef>
-          <a:effectRef idx="2">
-            <a:schemeClr val="accent1"/>
-          </a:effectRef>
-          <a:fontRef idx="minor">
-            <a:schemeClr val="lt1"/>
-          </a:fontRef>
-        </p:style>
-        <p:txBody>
-          <a:bodyPr rtlCol="0" anchor="ctr"/>
-          <a:lstStyle/>
-          <a:p>
-            <a:pPr algn="ctr"/>
-          </a:p>
-        </p:txBody>
-      </p:sp>
-      <p:sp>
-        <p:nvSpPr>
-          <p:cNvPr id="19" name="TextBox 18"/>
-          <p:cNvSpPr txBox="1"/>
-          <p:nvPr/>
-        </p:nvSpPr>
-        <p:spPr>
-          <a:xfrm>
-            <a:off x="6400800" y="2971800"/>
-            <a:ext cx="731520" cy="594360"/>
-          </a:xfrm>
-          <a:prstGeom prst="rect">
-            <a:avLst/>
-          </a:prstGeom>
-          <a:noFill/>
-        </p:spPr>
-        <p:txBody>
-          <a:bodyPr wrap="square">
-            <a:spAutoFit/>
-          </a:bodyPr>
-          <a:lstStyle/>
-          <a:p>
-            <a:pPr algn="l"/>
-            <a:r>
-              <a:rPr sz="2800" b="1" i="0">
-                <a:solidFill>
-                  <a:srgbClr val="00B4D8"/>
-                </a:solidFill>
-              </a:rPr>
-              <a:t>04</a:t>
-            </a:r>
-          </a:p>
-        </p:txBody>
-      </p:sp>
-      <p:sp>
-        <p:nvSpPr>
-          <p:cNvPr id="20" name="TextBox 19"/>
-          <p:cNvSpPr txBox="1"/>
-          <p:nvPr/>
-        </p:nvSpPr>
-        <p:spPr>
-          <a:xfrm>
-            <a:off x="7132320" y="2971800"/>
-            <a:ext cx="4389120" cy="411480"/>
-          </a:xfrm>
-          <a:prstGeom prst="rect">
-            <a:avLst/>
-          </a:prstGeom>
-          <a:noFill/>
-        </p:spPr>
-        <p:txBody>
-          <a:bodyPr wrap="square">
-            <a:spAutoFit/>
-          </a:bodyPr>
-          <a:lstStyle/>
-          <a:p>
-            <a:pPr algn="l"/>
-            <a:r>
-              <a:rPr sz="1500" b="1" i="0">
-                <a:solidFill>
-                  <a:srgbClr val="FFFFFF"/>
-                </a:solidFill>
-              </a:rPr>
-              <a:t>Key Features</a:t>
-            </a:r>
-          </a:p>
-        </p:txBody>
-      </p:sp>
-      <p:sp>
-        <p:nvSpPr>
-          <p:cNvPr id="21" name="TextBox 20"/>
-          <p:cNvSpPr txBox="1"/>
-          <p:nvPr/>
-        </p:nvSpPr>
-        <p:spPr>
-          <a:xfrm>
-            <a:off x="7132320" y="3383280"/>
-            <a:ext cx="4389120" cy="502920"/>
-          </a:xfrm>
-          <a:prstGeom prst="rect">
-            <a:avLst/>
-          </a:prstGeom>
-          <a:noFill/>
-        </p:spPr>
-        <p:txBody>
-          <a:bodyPr wrap="square">
-            <a:spAutoFit/>
-          </a:bodyPr>
-          <a:lstStyle/>
-          <a:p>
-            <a:pPr algn="l"/>
-            <a:r>
-              <a:rPr sz="1100" b="0" i="0">
-                <a:solidFill>
-                  <a:srgbClr val="94A3B8"/>
-                </a:solidFill>
-              </a:rPr>
-              <a:t>10 modules, AI assist, wave compare &amp; more</a:t>
-            </a:r>
-          </a:p>
-        </p:txBody>
-      </p:sp>
-      <p:sp>
-        <p:nvSpPr>
-          <p:cNvPr id="22" name="Rectangle 21"/>
-          <p:cNvSpPr/>
-          <p:nvPr/>
-        </p:nvSpPr>
-        <p:spPr>
-          <a:xfrm>
-            <a:off x="365760" y="4297680"/>
-            <a:ext cx="5577840" cy="1234440"/>
-          </a:xfrm>
-          <a:prstGeom prst="rect">
-            <a:avLst/>
-          </a:prstGeom>
-          <a:solidFill>
-            <a:srgbClr val="162A40"/>
-          </a:solidFill>
-          <a:ln>
-            <a:noFill/>
-          </a:ln>
-        </p:spPr>
-        <p:style>
-          <a:lnRef idx="1">
-            <a:schemeClr val="accent1"/>
-          </a:lnRef>
-          <a:fillRef idx="3">
-            <a:schemeClr val="accent1"/>
-          </a:fillRef>
-          <a:effectRef idx="2">
-            <a:schemeClr val="accent1"/>
-          </a:effectRef>
-          <a:fontRef idx="minor">
-            <a:schemeClr val="lt1"/>
-          </a:fontRef>
-        </p:style>
-        <p:txBody>
-          <a:bodyPr rtlCol="0" anchor="ctr"/>
-          <a:lstStyle/>
-          <a:p>
-            <a:pPr algn="ctr"/>
-          </a:p>
-        </p:txBody>
-      </p:sp>
-      <p:sp>
-        <p:nvSpPr>
-          <p:cNvPr id="23" name="TextBox 22"/>
-          <p:cNvSpPr txBox="1"/>
-          <p:nvPr/>
-        </p:nvSpPr>
-        <p:spPr>
-          <a:xfrm>
-            <a:off x="548640" y="4434840"/>
-            <a:ext cx="731520" cy="594360"/>
-          </a:xfrm>
-          <a:prstGeom prst="rect">
-            <a:avLst/>
-          </a:prstGeom>
-          <a:noFill/>
-        </p:spPr>
-        <p:txBody>
-          <a:bodyPr wrap="square">
-            <a:spAutoFit/>
-          </a:bodyPr>
-          <a:lstStyle/>
-          <a:p>
-            <a:pPr algn="l"/>
-            <a:r>
-              <a:rPr sz="2800" b="1" i="0">
-                <a:solidFill>
-                  <a:srgbClr val="00B4D8"/>
-                </a:solidFill>
-              </a:rPr>
-              <a:t>05</a:t>
-            </a:r>
-          </a:p>
-        </p:txBody>
-      </p:sp>
-      <p:sp>
-        <p:nvSpPr>
-          <p:cNvPr id="24" name="TextBox 23"/>
-          <p:cNvSpPr txBox="1"/>
-          <p:nvPr/>
-        </p:nvSpPr>
-        <p:spPr>
-          <a:xfrm>
-            <a:off x="1280160" y="4434840"/>
-            <a:ext cx="4389120" cy="411480"/>
-          </a:xfrm>
-          <a:prstGeom prst="rect">
-            <a:avLst/>
-          </a:prstGeom>
-          <a:noFill/>
-        </p:spPr>
-        <p:txBody>
-          <a:bodyPr wrap="square">
-            <a:spAutoFit/>
-          </a:bodyPr>
-          <a:lstStyle/>
-          <a:p>
-            <a:pPr algn="l"/>
-            <a:r>
-              <a:rPr sz="1500" b="1" i="0">
-                <a:solidFill>
-                  <a:srgbClr val="FFFFFF"/>
-                </a:solidFill>
-              </a:rPr>
-              <a:t>Technical Architecture</a:t>
-            </a:r>
-          </a:p>
-        </p:txBody>
-      </p:sp>
-      <p:sp>
-        <p:nvSpPr>
-          <p:cNvPr id="25" name="TextBox 24"/>
-          <p:cNvSpPr txBox="1"/>
-          <p:nvPr/>
-        </p:nvSpPr>
-        <p:spPr>
-          <a:xfrm>
-            <a:off x="1280160" y="4846320"/>
-            <a:ext cx="4389120" cy="502920"/>
-          </a:xfrm>
-          <a:prstGeom prst="rect">
-            <a:avLst/>
-          </a:prstGeom>
-          <a:noFill/>
-        </p:spPr>
-        <p:txBody>
-          <a:bodyPr wrap="square">
-            <a:spAutoFit/>
-          </a:bodyPr>
-          <a:lstStyle/>
-          <a:p>
-            <a:pPr algn="l"/>
-            <a:r>
-              <a:rPr sz="1100" b="0" i="0">
-                <a:solidFill>
-                  <a:srgbClr val="94A3B8"/>
-                </a:solidFill>
-              </a:rPr>
-              <a:t>Stack, pipeline &amp; deployment</a:t>
-            </a:r>
-          </a:p>
-        </p:txBody>
-      </p:sp>
-      <p:sp>
-        <p:nvSpPr>
-          <p:cNvPr id="26" name="Rectangle 25"/>
-          <p:cNvSpPr/>
-          <p:nvPr/>
-        </p:nvSpPr>
-        <p:spPr>
-          <a:xfrm>
-            <a:off x="6217920" y="4297680"/>
-            <a:ext cx="5577840" cy="1234440"/>
-          </a:xfrm>
-          <a:prstGeom prst="rect">
-            <a:avLst/>
-          </a:prstGeom>
-          <a:solidFill>
-            <a:srgbClr val="162A40"/>
-          </a:solidFill>
-          <a:ln>
-            <a:noFill/>
-          </a:ln>
-        </p:spPr>
-        <p:style>
-          <a:lnRef idx="1">
-            <a:schemeClr val="accent1"/>
-          </a:lnRef>
-          <a:fillRef idx="3">
-            <a:schemeClr val="accent1"/>
-          </a:fillRef>
-          <a:effectRef idx="2">
-            <a:schemeClr val="accent1"/>
-          </a:effectRef>
-          <a:fontRef idx="minor">
-            <a:schemeClr val="lt1"/>
-          </a:fontRef>
-        </p:style>
-        <p:txBody>
-          <a:bodyPr rtlCol="0" anchor="ctr"/>
-          <a:lstStyle/>
-          <a:p>
-            <a:pPr algn="ctr"/>
-          </a:p>
-        </p:txBody>
-      </p:sp>
-      <p:sp>
-        <p:nvSpPr>
-          <p:cNvPr id="27" name="TextBox 26"/>
-          <p:cNvSpPr txBox="1"/>
-          <p:nvPr/>
-        </p:nvSpPr>
-        <p:spPr>
-          <a:xfrm>
-            <a:off x="6400800" y="4434840"/>
-            <a:ext cx="731520" cy="594360"/>
-          </a:xfrm>
-          <a:prstGeom prst="rect">
-            <a:avLst/>
-          </a:prstGeom>
-          <a:noFill/>
-        </p:spPr>
-        <p:txBody>
-          <a:bodyPr wrap="square">
-            <a:spAutoFit/>
-          </a:bodyPr>
-          <a:lstStyle/>
-          <a:p>
-            <a:pPr algn="l"/>
-            <a:r>
-              <a:rPr sz="2800" b="1" i="0">
-                <a:solidFill>
-                  <a:srgbClr val="00B4D8"/>
-                </a:solidFill>
-              </a:rPr>
-              <a:t>06</a:t>
-            </a:r>
-          </a:p>
-        </p:txBody>
-      </p:sp>
-      <p:sp>
-        <p:nvSpPr>
-          <p:cNvPr id="28" name="TextBox 27"/>
-          <p:cNvSpPr txBox="1"/>
-          <p:nvPr/>
-        </p:nvSpPr>
-        <p:spPr>
-          <a:xfrm>
-            <a:off x="7132320" y="4434840"/>
-            <a:ext cx="4389120" cy="411480"/>
-          </a:xfrm>
-          <a:prstGeom prst="rect">
-            <a:avLst/>
-          </a:prstGeom>
-          <a:noFill/>
-        </p:spPr>
-        <p:txBody>
-          <a:bodyPr wrap="square">
-            <a:spAutoFit/>
-          </a:bodyPr>
-          <a:lstStyle/>
-          <a:p>
-            <a:pPr algn="l"/>
-            <a:r>
-              <a:rPr sz="1500" b="1" i="0">
-                <a:solidFill>
-                  <a:srgbClr val="FFFFFF"/>
-                </a:solidFill>
-              </a:rPr>
-              <a:t>Summary &amp; Next Steps</a:t>
-            </a:r>
-          </a:p>
-        </p:txBody>
-      </p:sp>
-      <p:sp>
-        <p:nvSpPr>
-          <p:cNvPr id="29" name="TextBox 28"/>
-          <p:cNvSpPr txBox="1"/>
-          <p:nvPr/>
-        </p:nvSpPr>
-        <p:spPr>
-          <a:xfrm>
-            <a:off x="7132320" y="4846320"/>
-            <a:ext cx="4389120" cy="502920"/>
-          </a:xfrm>
-          <a:prstGeom prst="rect">
-            <a:avLst/>
-          </a:prstGeom>
-          <a:noFill/>
-        </p:spPr>
-        <p:txBody>
-          <a:bodyPr wrap="square">
-            <a:spAutoFit/>
-          </a:bodyPr>
-          <a:lstStyle/>
-          <a:p>
-            <a:pPr algn="l"/>
-            <a:r>
-              <a:rPr sz="1100" b="0" i="0">
-                <a:solidFill>
-                  <a:srgbClr val="94A3B8"/>
-                </a:solidFill>
-              </a:rPr>
-              <a:t>Rollout plan &amp; contacts</a:t>
             </a:r>
           </a:p>
         </p:txBody>
@@ -7288,7 +5090,7 @@
                   <a:srgbClr val="94A3B8"/>
                 </a:solidFill>
               </a:rPr>
-              <a:t>Reduce QC cycle time from days to minutes. Analysts get clean data faster, accelerating insight delivery.</a:t>
+              <a:t>Cut QC cycle time from 4+ hours to under 60 seconds. Analysts receive clean data the same day fieldwork closes.</a:t>
             </a:r>
           </a:p>
         </p:txBody>
@@ -7433,7 +5235,7 @@
                   <a:srgbClr val="94A3B8"/>
                 </a:solidFill>
               </a:rPr>
-              <a:t>Catch interviewer fraud, data fabrication, and logic errors before they corrupt results or damage client trust.</a:t>
+              <a:t>Detect 3× more interviewer fraud cases than manual review. Flag fabricated responses and logic errors before delivery.</a:t>
             </a:r>
           </a:p>
         </p:txBody>
@@ -7578,7 +5380,7 @@
                   <a:srgbClr val="94A3B8"/>
                 </a:solidFill>
               </a:rPr>
-              <a:t>Eliminate hours of manual data cleaning. Redeploy QC analyst time to higher-value interpretation work.</a:t>
+              <a:t>Reduce QC staffing from 5 analysts per study to 2 — a 60% cost reduction. Redeploy senior analysts to insight work.</a:t>
             </a:r>
           </a:p>
         </p:txBody>
@@ -7723,7 +5525,7 @@
                   <a:srgbClr val="94A3B8"/>
                 </a:solidFill>
               </a:rPr>
-              <a:t>Rule-based checks apply the same standard to every dataset — no human variation, no missed edge cases.</a:t>
+              <a:t>Apply 200+ configurable rules consistently across every dataset — 0% human variation, 0% missed edge cases.</a:t>
             </a:r>
           </a:p>
         </p:txBody>
@@ -7868,7 +5670,7 @@
                   <a:srgbClr val="94A3B8"/>
                 </a:solidFill>
               </a:rPr>
-              <a:t>Every flagged issue is logged with row-level evidence. Full transparency for client reporting and compliance.</a:t>
+              <a:t>100% row-level traceability on every flagged issue. Audit-ready reports delivered in minutes, not days.</a:t>
             </a:r>
           </a:p>
         </p:txBody>
@@ -8013,7 +5815,7 @@
                   <a:srgbClr val="94A3B8"/>
                 </a:solidFill>
               </a:rPr>
-              <a:t>Handle large longitudinal studies with wave-over-wave comparison. Scales with your survey volume.</a:t>
+              <a:t>Process 100,000+ row datasets in under 2 minutes. Wave-over-wave comparison handles multi-month tracking studies.</a:t>
             </a:r>
           </a:p>
         </p:txBody>
@@ -13548,1295 +11350,6 @@
 </p:sld>
 </file>
 
-<file path=ppt/slides/slide8.xml><?xml version="1.0" encoding="utf-8"?>
-<p:sld xmlns:a="http://schemas.openxmlformats.org/drawingml/2006/main" xmlns:p="http://schemas.openxmlformats.org/presentationml/2006/main" xmlns:r="http://schemas.openxmlformats.org/officeDocument/2006/relationships">
-  <p:cSld>
-    <p:spTree>
-      <p:nvGrpSpPr>
-        <p:cNvPr id="1" name=""/>
-        <p:cNvGrpSpPr/>
-        <p:nvPr/>
-      </p:nvGrpSpPr>
-      <p:grpSpPr/>
-      <p:sp>
-        <p:nvSpPr>
-          <p:cNvPr id="2" name="Rectangle 1"/>
-          <p:cNvSpPr/>
-          <p:nvPr/>
-        </p:nvSpPr>
-        <p:spPr>
-          <a:xfrm>
-            <a:off x="0" y="0"/>
-            <a:ext cx="12188952" cy="6858000"/>
-          </a:xfrm>
-          <a:prstGeom prst="rect">
-            <a:avLst/>
-          </a:prstGeom>
-          <a:solidFill>
-            <a:srgbClr val="0D1B2A"/>
-          </a:solidFill>
-          <a:ln>
-            <a:noFill/>
-          </a:ln>
-        </p:spPr>
-        <p:style>
-          <a:lnRef idx="1">
-            <a:schemeClr val="accent1"/>
-          </a:lnRef>
-          <a:fillRef idx="3">
-            <a:schemeClr val="accent1"/>
-          </a:fillRef>
-          <a:effectRef idx="2">
-            <a:schemeClr val="accent1"/>
-          </a:effectRef>
-          <a:fontRef idx="minor">
-            <a:schemeClr val="lt1"/>
-          </a:fontRef>
-        </p:style>
-        <p:txBody>
-          <a:bodyPr rtlCol="0" anchor="ctr"/>
-          <a:lstStyle/>
-          <a:p>
-            <a:pPr algn="ctr"/>
-          </a:p>
-        </p:txBody>
-      </p:sp>
-      <p:sp>
-        <p:nvSpPr>
-          <p:cNvPr id="3" name="Rectangle 2"/>
-          <p:cNvSpPr/>
-          <p:nvPr/>
-        </p:nvSpPr>
-        <p:spPr>
-          <a:xfrm>
-            <a:off x="0" y="0"/>
-            <a:ext cx="73152" cy="6858000"/>
-          </a:xfrm>
-          <a:prstGeom prst="rect">
-            <a:avLst/>
-          </a:prstGeom>
-          <a:solidFill>
-            <a:srgbClr val="00B4D8"/>
-          </a:solidFill>
-          <a:ln>
-            <a:noFill/>
-          </a:ln>
-        </p:spPr>
-        <p:style>
-          <a:lnRef idx="1">
-            <a:schemeClr val="accent1"/>
-          </a:lnRef>
-          <a:fillRef idx="3">
-            <a:schemeClr val="accent1"/>
-          </a:fillRef>
-          <a:effectRef idx="2">
-            <a:schemeClr val="accent1"/>
-          </a:effectRef>
-          <a:fontRef idx="minor">
-            <a:schemeClr val="lt1"/>
-          </a:fontRef>
-        </p:style>
-        <p:txBody>
-          <a:bodyPr rtlCol="0" anchor="ctr"/>
-          <a:lstStyle/>
-          <a:p>
-            <a:pPr algn="ctr"/>
-          </a:p>
-        </p:txBody>
-      </p:sp>
-      <p:sp>
-        <p:nvSpPr>
-          <p:cNvPr id="4" name="TextBox 3"/>
-          <p:cNvSpPr txBox="1"/>
-          <p:nvPr/>
-        </p:nvSpPr>
-        <p:spPr>
-          <a:xfrm>
-            <a:off x="320040" y="256032"/>
-            <a:ext cx="11430000" cy="640080"/>
-          </a:xfrm>
-          <a:prstGeom prst="rect">
-            <a:avLst/>
-          </a:prstGeom>
-          <a:noFill/>
-        </p:spPr>
-        <p:txBody>
-          <a:bodyPr wrap="square">
-            <a:spAutoFit/>
-          </a:bodyPr>
-          <a:lstStyle/>
-          <a:p>
-            <a:pPr algn="l"/>
-            <a:r>
-              <a:rPr sz="3200" b="1" i="0">
-                <a:solidFill>
-                  <a:srgbClr val="00B4D8"/>
-                </a:solidFill>
-              </a:rPr>
-              <a:t>Technical Architecture</a:t>
-            </a:r>
-          </a:p>
-        </p:txBody>
-      </p:sp>
-      <p:sp>
-        <p:nvSpPr>
-          <p:cNvPr id="5" name="TextBox 4"/>
-          <p:cNvSpPr txBox="1"/>
-          <p:nvPr/>
-        </p:nvSpPr>
-        <p:spPr>
-          <a:xfrm>
-            <a:off x="320040" y="868680"/>
-            <a:ext cx="11430000" cy="365760"/>
-          </a:xfrm>
-          <a:prstGeom prst="rect">
-            <a:avLst/>
-          </a:prstGeom>
-          <a:noFill/>
-        </p:spPr>
-        <p:txBody>
-          <a:bodyPr wrap="square">
-            <a:spAutoFit/>
-          </a:bodyPr>
-          <a:lstStyle/>
-          <a:p>
-            <a:pPr algn="l"/>
-            <a:r>
-              <a:rPr sz="1400" b="0" i="0">
-                <a:solidFill>
-                  <a:srgbClr val="94A3B8"/>
-                </a:solidFill>
-              </a:rPr>
-              <a:t>Modern, API-first, cloud-deployable</a:t>
-            </a:r>
-          </a:p>
-        </p:txBody>
-      </p:sp>
-      <p:sp>
-        <p:nvSpPr>
-          <p:cNvPr id="6" name="Rectangle 5"/>
-          <p:cNvSpPr/>
-          <p:nvPr/>
-        </p:nvSpPr>
-        <p:spPr>
-          <a:xfrm>
-            <a:off x="320040" y="1417320"/>
-            <a:ext cx="3749039" cy="5029200"/>
-          </a:xfrm>
-          <a:prstGeom prst="rect">
-            <a:avLst/>
-          </a:prstGeom>
-          <a:solidFill>
-            <a:srgbClr val="162A40"/>
-          </a:solidFill>
-          <a:ln>
-            <a:noFill/>
-          </a:ln>
-        </p:spPr>
-        <p:style>
-          <a:lnRef idx="1">
-            <a:schemeClr val="accent1"/>
-          </a:lnRef>
-          <a:fillRef idx="3">
-            <a:schemeClr val="accent1"/>
-          </a:fillRef>
-          <a:effectRef idx="2">
-            <a:schemeClr val="accent1"/>
-          </a:effectRef>
-          <a:fontRef idx="minor">
-            <a:schemeClr val="lt1"/>
-          </a:fontRef>
-        </p:style>
-        <p:txBody>
-          <a:bodyPr rtlCol="0" anchor="ctr"/>
-          <a:lstStyle/>
-          <a:p>
-            <a:pPr algn="ctr"/>
-          </a:p>
-        </p:txBody>
-      </p:sp>
-      <p:sp>
-        <p:nvSpPr>
-          <p:cNvPr id="7" name="Rectangle 6"/>
-          <p:cNvSpPr/>
-          <p:nvPr/>
-        </p:nvSpPr>
-        <p:spPr>
-          <a:xfrm>
-            <a:off x="320040" y="1417320"/>
-            <a:ext cx="3749039" cy="411480"/>
-          </a:xfrm>
-          <a:prstGeom prst="rect">
-            <a:avLst/>
-          </a:prstGeom>
-          <a:solidFill>
-            <a:srgbClr val="00B4D8"/>
-          </a:solidFill>
-          <a:ln>
-            <a:noFill/>
-          </a:ln>
-        </p:spPr>
-        <p:style>
-          <a:lnRef idx="1">
-            <a:schemeClr val="accent1"/>
-          </a:lnRef>
-          <a:fillRef idx="3">
-            <a:schemeClr val="accent1"/>
-          </a:fillRef>
-          <a:effectRef idx="2">
-            <a:schemeClr val="accent1"/>
-          </a:effectRef>
-          <a:fontRef idx="minor">
-            <a:schemeClr val="lt1"/>
-          </a:fontRef>
-        </p:style>
-        <p:txBody>
-          <a:bodyPr rtlCol="0" anchor="ctr"/>
-          <a:lstStyle/>
-          <a:p>
-            <a:pPr algn="ctr"/>
-          </a:p>
-        </p:txBody>
-      </p:sp>
-      <p:sp>
-        <p:nvSpPr>
-          <p:cNvPr id="8" name="TextBox 7"/>
-          <p:cNvSpPr txBox="1"/>
-          <p:nvPr/>
-        </p:nvSpPr>
-        <p:spPr>
-          <a:xfrm>
-            <a:off x="320040" y="1463040"/>
-            <a:ext cx="3749039" cy="347472"/>
-          </a:xfrm>
-          <a:prstGeom prst="rect">
-            <a:avLst/>
-          </a:prstGeom>
-          <a:noFill/>
-        </p:spPr>
-        <p:txBody>
-          <a:bodyPr wrap="square">
-            <a:spAutoFit/>
-          </a:bodyPr>
-          <a:lstStyle/>
-          <a:p>
-            <a:pPr algn="ctr"/>
-            <a:r>
-              <a:rPr sz="1500" b="1" i="0">
-                <a:solidFill>
-                  <a:srgbClr val="0D1B2A"/>
-                </a:solidFill>
-              </a:rPr>
-              <a:t>Frontend</a:t>
-            </a:r>
-          </a:p>
-        </p:txBody>
-      </p:sp>
-      <p:sp>
-        <p:nvSpPr>
-          <p:cNvPr id="9" name="TextBox 8"/>
-          <p:cNvSpPr txBox="1"/>
-          <p:nvPr/>
-        </p:nvSpPr>
-        <p:spPr>
-          <a:xfrm>
-            <a:off x="502920" y="1965960"/>
-            <a:ext cx="3383280" cy="320040"/>
-          </a:xfrm>
-          <a:prstGeom prst="rect">
-            <a:avLst/>
-          </a:prstGeom>
-          <a:noFill/>
-        </p:spPr>
-        <p:txBody>
-          <a:bodyPr wrap="square">
-            <a:spAutoFit/>
-          </a:bodyPr>
-          <a:lstStyle/>
-          <a:p>
-            <a:pPr algn="l"/>
-            <a:r>
-              <a:rPr sz="1100" b="0" i="0">
-                <a:solidFill>
-                  <a:srgbClr val="FFFFFF"/>
-                </a:solidFill>
-              </a:rPr>
-              <a:t>▸  React + TypeScript + Vite</a:t>
-            </a:r>
-          </a:p>
-        </p:txBody>
-      </p:sp>
-      <p:sp>
-        <p:nvSpPr>
-          <p:cNvPr id="10" name="TextBox 9"/>
-          <p:cNvSpPr txBox="1"/>
-          <p:nvPr/>
-        </p:nvSpPr>
-        <p:spPr>
-          <a:xfrm>
-            <a:off x="502920" y="2651760"/>
-            <a:ext cx="3383280" cy="320040"/>
-          </a:xfrm>
-          <a:prstGeom prst="rect">
-            <a:avLst/>
-          </a:prstGeom>
-          <a:noFill/>
-        </p:spPr>
-        <p:txBody>
-          <a:bodyPr wrap="square">
-            <a:spAutoFit/>
-          </a:bodyPr>
-          <a:lstStyle/>
-          <a:p>
-            <a:pPr algn="l"/>
-            <a:r>
-              <a:rPr sz="1100" b="0" i="0">
-                <a:solidFill>
-                  <a:srgbClr val="FFFFFF"/>
-                </a:solidFill>
-              </a:rPr>
-              <a:t>▸  Tailwind CSS (dark theme)</a:t>
-            </a:r>
-          </a:p>
-        </p:txBody>
-      </p:sp>
-      <p:sp>
-        <p:nvSpPr>
-          <p:cNvPr id="11" name="TextBox 10"/>
-          <p:cNvSpPr txBox="1"/>
-          <p:nvPr/>
-        </p:nvSpPr>
-        <p:spPr>
-          <a:xfrm>
-            <a:off x="502920" y="3337560"/>
-            <a:ext cx="3383280" cy="320040"/>
-          </a:xfrm>
-          <a:prstGeom prst="rect">
-            <a:avLst/>
-          </a:prstGeom>
-          <a:noFill/>
-        </p:spPr>
-        <p:txBody>
-          <a:bodyPr wrap="square">
-            <a:spAutoFit/>
-          </a:bodyPr>
-          <a:lstStyle/>
-          <a:p>
-            <a:pPr algn="l"/>
-            <a:r>
-              <a:rPr sz="1100" b="0" i="0">
-                <a:solidFill>
-                  <a:srgbClr val="FFFFFF"/>
-                </a:solidFill>
-              </a:rPr>
-              <a:t>▸  Zustand state management</a:t>
-            </a:r>
-          </a:p>
-        </p:txBody>
-      </p:sp>
-      <p:sp>
-        <p:nvSpPr>
-          <p:cNvPr id="12" name="TextBox 11"/>
-          <p:cNvSpPr txBox="1"/>
-          <p:nvPr/>
-        </p:nvSpPr>
-        <p:spPr>
-          <a:xfrm>
-            <a:off x="502920" y="4023360"/>
-            <a:ext cx="3383280" cy="320040"/>
-          </a:xfrm>
-          <a:prstGeom prst="rect">
-            <a:avLst/>
-          </a:prstGeom>
-          <a:noFill/>
-        </p:spPr>
-        <p:txBody>
-          <a:bodyPr wrap="square">
-            <a:spAutoFit/>
-          </a:bodyPr>
-          <a:lstStyle/>
-          <a:p>
-            <a:pPr algn="l"/>
-            <a:r>
-              <a:rPr sz="1100" b="0" i="0">
-                <a:solidFill>
-                  <a:srgbClr val="FFFFFF"/>
-                </a:solidFill>
-              </a:rPr>
-              <a:t>▸  Axios API client</a:t>
-            </a:r>
-          </a:p>
-        </p:txBody>
-      </p:sp>
-      <p:sp>
-        <p:nvSpPr>
-          <p:cNvPr id="13" name="TextBox 12"/>
-          <p:cNvSpPr txBox="1"/>
-          <p:nvPr/>
-        </p:nvSpPr>
-        <p:spPr>
-          <a:xfrm>
-            <a:off x="502920" y="4709160"/>
-            <a:ext cx="3383280" cy="320040"/>
-          </a:xfrm>
-          <a:prstGeom prst="rect">
-            <a:avLst/>
-          </a:prstGeom>
-          <a:noFill/>
-        </p:spPr>
-        <p:txBody>
-          <a:bodyPr wrap="square">
-            <a:spAutoFit/>
-          </a:bodyPr>
-          <a:lstStyle/>
-          <a:p>
-            <a:pPr algn="l"/>
-            <a:r>
-              <a:rPr sz="1100" b="0" i="0">
-                <a:solidFill>
-                  <a:srgbClr val="FFFFFF"/>
-                </a:solidFill>
-              </a:rPr>
-              <a:t>▸  10 analysis tabs</a:t>
-            </a:r>
-          </a:p>
-        </p:txBody>
-      </p:sp>
-      <p:sp>
-        <p:nvSpPr>
-          <p:cNvPr id="14" name="TextBox 13"/>
-          <p:cNvSpPr txBox="1"/>
-          <p:nvPr/>
-        </p:nvSpPr>
-        <p:spPr>
-          <a:xfrm>
-            <a:off x="502920" y="5394960"/>
-            <a:ext cx="3383280" cy="320040"/>
-          </a:xfrm>
-          <a:prstGeom prst="rect">
-            <a:avLst/>
-          </a:prstGeom>
-          <a:noFill/>
-        </p:spPr>
-        <p:txBody>
-          <a:bodyPr wrap="square">
-            <a:spAutoFit/>
-          </a:bodyPr>
-          <a:lstStyle/>
-          <a:p>
-            <a:pPr algn="l"/>
-            <a:r>
-              <a:rPr sz="1100" b="0" i="0">
-                <a:solidFill>
-                  <a:srgbClr val="FFFFFF"/>
-                </a:solidFill>
-              </a:rPr>
-              <a:t>▸  Deployed via Vercel</a:t>
-            </a:r>
-          </a:p>
-        </p:txBody>
-      </p:sp>
-      <p:sp>
-        <p:nvSpPr>
-          <p:cNvPr id="15" name="Rectangle 14"/>
-          <p:cNvSpPr/>
-          <p:nvPr/>
-        </p:nvSpPr>
-        <p:spPr>
-          <a:xfrm>
-            <a:off x="4251960" y="1417320"/>
-            <a:ext cx="3749039" cy="5029200"/>
-          </a:xfrm>
-          <a:prstGeom prst="rect">
-            <a:avLst/>
-          </a:prstGeom>
-          <a:solidFill>
-            <a:srgbClr val="162A40"/>
-          </a:solidFill>
-          <a:ln>
-            <a:noFill/>
-          </a:ln>
-        </p:spPr>
-        <p:style>
-          <a:lnRef idx="1">
-            <a:schemeClr val="accent1"/>
-          </a:lnRef>
-          <a:fillRef idx="3">
-            <a:schemeClr val="accent1"/>
-          </a:fillRef>
-          <a:effectRef idx="2">
-            <a:schemeClr val="accent1"/>
-          </a:effectRef>
-          <a:fontRef idx="minor">
-            <a:schemeClr val="lt1"/>
-          </a:fontRef>
-        </p:style>
-        <p:txBody>
-          <a:bodyPr rtlCol="0" anchor="ctr"/>
-          <a:lstStyle/>
-          <a:p>
-            <a:pPr algn="ctr"/>
-          </a:p>
-        </p:txBody>
-      </p:sp>
-      <p:sp>
-        <p:nvSpPr>
-          <p:cNvPr id="16" name="Rectangle 15"/>
-          <p:cNvSpPr/>
-          <p:nvPr/>
-        </p:nvSpPr>
-        <p:spPr>
-          <a:xfrm>
-            <a:off x="4251960" y="1417320"/>
-            <a:ext cx="3749039" cy="411480"/>
-          </a:xfrm>
-          <a:prstGeom prst="rect">
-            <a:avLst/>
-          </a:prstGeom>
-          <a:solidFill>
-            <a:srgbClr val="10B981"/>
-          </a:solidFill>
-          <a:ln>
-            <a:noFill/>
-          </a:ln>
-        </p:spPr>
-        <p:style>
-          <a:lnRef idx="1">
-            <a:schemeClr val="accent1"/>
-          </a:lnRef>
-          <a:fillRef idx="3">
-            <a:schemeClr val="accent1"/>
-          </a:fillRef>
-          <a:effectRef idx="2">
-            <a:schemeClr val="accent1"/>
-          </a:effectRef>
-          <a:fontRef idx="minor">
-            <a:schemeClr val="lt1"/>
-          </a:fontRef>
-        </p:style>
-        <p:txBody>
-          <a:bodyPr rtlCol="0" anchor="ctr"/>
-          <a:lstStyle/>
-          <a:p>
-            <a:pPr algn="ctr"/>
-          </a:p>
-        </p:txBody>
-      </p:sp>
-      <p:sp>
-        <p:nvSpPr>
-          <p:cNvPr id="17" name="TextBox 16"/>
-          <p:cNvSpPr txBox="1"/>
-          <p:nvPr/>
-        </p:nvSpPr>
-        <p:spPr>
-          <a:xfrm>
-            <a:off x="4251960" y="1463040"/>
-            <a:ext cx="3749039" cy="347472"/>
-          </a:xfrm>
-          <a:prstGeom prst="rect">
-            <a:avLst/>
-          </a:prstGeom>
-          <a:noFill/>
-        </p:spPr>
-        <p:txBody>
-          <a:bodyPr wrap="square">
-            <a:spAutoFit/>
-          </a:bodyPr>
-          <a:lstStyle/>
-          <a:p>
-            <a:pPr algn="ctr"/>
-            <a:r>
-              <a:rPr sz="1500" b="1" i="0">
-                <a:solidFill>
-                  <a:srgbClr val="0D1B2A"/>
-                </a:solidFill>
-              </a:rPr>
-              <a:t>Backend API</a:t>
-            </a:r>
-          </a:p>
-        </p:txBody>
-      </p:sp>
-      <p:sp>
-        <p:nvSpPr>
-          <p:cNvPr id="18" name="TextBox 17"/>
-          <p:cNvSpPr txBox="1"/>
-          <p:nvPr/>
-        </p:nvSpPr>
-        <p:spPr>
-          <a:xfrm>
-            <a:off x="4434840" y="1965960"/>
-            <a:ext cx="3383280" cy="320040"/>
-          </a:xfrm>
-          <a:prstGeom prst="rect">
-            <a:avLst/>
-          </a:prstGeom>
-          <a:noFill/>
-        </p:spPr>
-        <p:txBody>
-          <a:bodyPr wrap="square">
-            <a:spAutoFit/>
-          </a:bodyPr>
-          <a:lstStyle/>
-          <a:p>
-            <a:pPr algn="l"/>
-            <a:r>
-              <a:rPr sz="1100" b="0" i="0">
-                <a:solidFill>
-                  <a:srgbClr val="FFFFFF"/>
-                </a:solidFill>
-              </a:rPr>
-              <a:t>▸  FastAPI (Python 3.12)</a:t>
-            </a:r>
-          </a:p>
-        </p:txBody>
-      </p:sp>
-      <p:sp>
-        <p:nvSpPr>
-          <p:cNvPr id="19" name="TextBox 18"/>
-          <p:cNvSpPr txBox="1"/>
-          <p:nvPr/>
-        </p:nvSpPr>
-        <p:spPr>
-          <a:xfrm>
-            <a:off x="4434840" y="2651760"/>
-            <a:ext cx="3383280" cy="320040"/>
-          </a:xfrm>
-          <a:prstGeom prst="rect">
-            <a:avLst/>
-          </a:prstGeom>
-          <a:noFill/>
-        </p:spPr>
-        <p:txBody>
-          <a:bodyPr wrap="square">
-            <a:spAutoFit/>
-          </a:bodyPr>
-          <a:lstStyle/>
-          <a:p>
-            <a:pPr algn="l"/>
-            <a:r>
-              <a:rPr sz="1100" b="0" i="0">
-                <a:solidFill>
-                  <a:srgbClr val="FFFFFF"/>
-                </a:solidFill>
-              </a:rPr>
-              <a:t>▸  Pydantic request validation</a:t>
-            </a:r>
-          </a:p>
-        </p:txBody>
-      </p:sp>
-      <p:sp>
-        <p:nvSpPr>
-          <p:cNvPr id="20" name="TextBox 19"/>
-          <p:cNvSpPr txBox="1"/>
-          <p:nvPr/>
-        </p:nvSpPr>
-        <p:spPr>
-          <a:xfrm>
-            <a:off x="4434840" y="3337560"/>
-            <a:ext cx="3383280" cy="320040"/>
-          </a:xfrm>
-          <a:prstGeom prst="rect">
-            <a:avLst/>
-          </a:prstGeom>
-          <a:noFill/>
-        </p:spPr>
-        <p:txBody>
-          <a:bodyPr wrap="square">
-            <a:spAutoFit/>
-          </a:bodyPr>
-          <a:lstStyle/>
-          <a:p>
-            <a:pPr algn="l"/>
-            <a:r>
-              <a:rPr sz="1100" b="0" i="0">
-                <a:solidFill>
-                  <a:srgbClr val="FFFFFF"/>
-                </a:solidFill>
-              </a:rPr>
-              <a:t>▸  In-memory job registry</a:t>
-            </a:r>
-          </a:p>
-        </p:txBody>
-      </p:sp>
-      <p:sp>
-        <p:nvSpPr>
-          <p:cNvPr id="21" name="TextBox 20"/>
-          <p:cNvSpPr txBox="1"/>
-          <p:nvPr/>
-        </p:nvSpPr>
-        <p:spPr>
-          <a:xfrm>
-            <a:off x="4434840" y="4023360"/>
-            <a:ext cx="3383280" cy="320040"/>
-          </a:xfrm>
-          <a:prstGeom prst="rect">
-            <a:avLst/>
-          </a:prstGeom>
-          <a:noFill/>
-        </p:spPr>
-        <p:txBody>
-          <a:bodyPr wrap="square">
-            <a:spAutoFit/>
-          </a:bodyPr>
-          <a:lstStyle/>
-          <a:p>
-            <a:pPr algn="l"/>
-            <a:r>
-              <a:rPr sz="1100" b="0" i="0">
-                <a:solidFill>
-                  <a:srgbClr val="FFFFFF"/>
-                </a:solidFill>
-              </a:rPr>
-              <a:t>▸  Auto temp-file cleanup</a:t>
-            </a:r>
-          </a:p>
-        </p:txBody>
-      </p:sp>
-      <p:sp>
-        <p:nvSpPr>
-          <p:cNvPr id="22" name="TextBox 21"/>
-          <p:cNvSpPr txBox="1"/>
-          <p:nvPr/>
-        </p:nvSpPr>
-        <p:spPr>
-          <a:xfrm>
-            <a:off x="4434840" y="4709160"/>
-            <a:ext cx="3383280" cy="320040"/>
-          </a:xfrm>
-          <a:prstGeom prst="rect">
-            <a:avLst/>
-          </a:prstGeom>
-          <a:noFill/>
-        </p:spPr>
-        <p:txBody>
-          <a:bodyPr wrap="square">
-            <a:spAutoFit/>
-          </a:bodyPr>
-          <a:lstStyle/>
-          <a:p>
-            <a:pPr algn="l"/>
-            <a:r>
-              <a:rPr sz="1100" b="0" i="0">
-                <a:solidFill>
-                  <a:srgbClr val="FFFFFF"/>
-                </a:solidFill>
-              </a:rPr>
-              <a:t>▸  Groq AI integration</a:t>
-            </a:r>
-          </a:p>
-        </p:txBody>
-      </p:sp>
-      <p:sp>
-        <p:nvSpPr>
-          <p:cNvPr id="23" name="TextBox 22"/>
-          <p:cNvSpPr txBox="1"/>
-          <p:nvPr/>
-        </p:nvSpPr>
-        <p:spPr>
-          <a:xfrm>
-            <a:off x="4434840" y="5394960"/>
-            <a:ext cx="3383280" cy="320040"/>
-          </a:xfrm>
-          <a:prstGeom prst="rect">
-            <a:avLst/>
-          </a:prstGeom>
-          <a:noFill/>
-        </p:spPr>
-        <p:txBody>
-          <a:bodyPr wrap="square">
-            <a:spAutoFit/>
-          </a:bodyPr>
-          <a:lstStyle/>
-          <a:p>
-            <a:pPr algn="l"/>
-            <a:r>
-              <a:rPr sz="1100" b="0" i="0">
-                <a:solidFill>
-                  <a:srgbClr val="FFFFFF"/>
-                </a:solidFill>
-              </a:rPr>
-              <a:t>▸  Deployed via Render / Fly</a:t>
-            </a:r>
-          </a:p>
-        </p:txBody>
-      </p:sp>
-      <p:sp>
-        <p:nvSpPr>
-          <p:cNvPr id="24" name="Rectangle 23"/>
-          <p:cNvSpPr/>
-          <p:nvPr/>
-        </p:nvSpPr>
-        <p:spPr>
-          <a:xfrm>
-            <a:off x="8183880" y="1417320"/>
-            <a:ext cx="3749039" cy="5029200"/>
-          </a:xfrm>
-          <a:prstGeom prst="rect">
-            <a:avLst/>
-          </a:prstGeom>
-          <a:solidFill>
-            <a:srgbClr val="162A40"/>
-          </a:solidFill>
-          <a:ln>
-            <a:noFill/>
-          </a:ln>
-        </p:spPr>
-        <p:style>
-          <a:lnRef idx="1">
-            <a:schemeClr val="accent1"/>
-          </a:lnRef>
-          <a:fillRef idx="3">
-            <a:schemeClr val="accent1"/>
-          </a:fillRef>
-          <a:effectRef idx="2">
-            <a:schemeClr val="accent1"/>
-          </a:effectRef>
-          <a:fontRef idx="minor">
-            <a:schemeClr val="lt1"/>
-          </a:fontRef>
-        </p:style>
-        <p:txBody>
-          <a:bodyPr rtlCol="0" anchor="ctr"/>
-          <a:lstStyle/>
-          <a:p>
-            <a:pPr algn="ctr"/>
-          </a:p>
-        </p:txBody>
-      </p:sp>
-      <p:sp>
-        <p:nvSpPr>
-          <p:cNvPr id="25" name="Rectangle 24"/>
-          <p:cNvSpPr/>
-          <p:nvPr/>
-        </p:nvSpPr>
-        <p:spPr>
-          <a:xfrm>
-            <a:off x="8183880" y="1417320"/>
-            <a:ext cx="3749039" cy="411480"/>
-          </a:xfrm>
-          <a:prstGeom prst="rect">
-            <a:avLst/>
-          </a:prstGeom>
-          <a:solidFill>
-            <a:srgbClr val="F59E0B"/>
-          </a:solidFill>
-          <a:ln>
-            <a:noFill/>
-          </a:ln>
-        </p:spPr>
-        <p:style>
-          <a:lnRef idx="1">
-            <a:schemeClr val="accent1"/>
-          </a:lnRef>
-          <a:fillRef idx="3">
-            <a:schemeClr val="accent1"/>
-          </a:fillRef>
-          <a:effectRef idx="2">
-            <a:schemeClr val="accent1"/>
-          </a:effectRef>
-          <a:fontRef idx="minor">
-            <a:schemeClr val="lt1"/>
-          </a:fontRef>
-        </p:style>
-        <p:txBody>
-          <a:bodyPr rtlCol="0" anchor="ctr"/>
-          <a:lstStyle/>
-          <a:p>
-            <a:pPr algn="ctr"/>
-          </a:p>
-        </p:txBody>
-      </p:sp>
-      <p:sp>
-        <p:nvSpPr>
-          <p:cNvPr id="26" name="TextBox 25"/>
-          <p:cNvSpPr txBox="1"/>
-          <p:nvPr/>
-        </p:nvSpPr>
-        <p:spPr>
-          <a:xfrm>
-            <a:off x="8183880" y="1463040"/>
-            <a:ext cx="3749039" cy="347472"/>
-          </a:xfrm>
-          <a:prstGeom prst="rect">
-            <a:avLst/>
-          </a:prstGeom>
-          <a:noFill/>
-        </p:spPr>
-        <p:txBody>
-          <a:bodyPr wrap="square">
-            <a:spAutoFit/>
-          </a:bodyPr>
-          <a:lstStyle/>
-          <a:p>
-            <a:pPr algn="ctr"/>
-            <a:r>
-              <a:rPr sz="1500" b="1" i="0">
-                <a:solidFill>
-                  <a:srgbClr val="0D1B2A"/>
-                </a:solidFill>
-              </a:rPr>
-              <a:t>QC Pipeline</a:t>
-            </a:r>
-          </a:p>
-        </p:txBody>
-      </p:sp>
-      <p:sp>
-        <p:nvSpPr>
-          <p:cNvPr id="27" name="TextBox 26"/>
-          <p:cNvSpPr txBox="1"/>
-          <p:nvPr/>
-        </p:nvSpPr>
-        <p:spPr>
-          <a:xfrm>
-            <a:off x="8366760" y="1965960"/>
-            <a:ext cx="3383280" cy="320040"/>
-          </a:xfrm>
-          <a:prstGeom prst="rect">
-            <a:avLst/>
-          </a:prstGeom>
-          <a:noFill/>
-        </p:spPr>
-        <p:txBody>
-          <a:bodyPr wrap="square">
-            <a:spAutoFit/>
-          </a:bodyPr>
-          <a:lstStyle/>
-          <a:p>
-            <a:pPr algn="l"/>
-            <a:r>
-              <a:rPr sz="1100" b="0" i="0">
-                <a:solidFill>
-                  <a:srgbClr val="FFFFFF"/>
-                </a:solidFill>
-              </a:rPr>
-              <a:t>▸  Load: CSV / XLSX / SAV</a:t>
-            </a:r>
-          </a:p>
-        </p:txBody>
-      </p:sp>
-      <p:sp>
-        <p:nvSpPr>
-          <p:cNvPr id="28" name="TextBox 27"/>
-          <p:cNvSpPr txBox="1"/>
-          <p:nvPr/>
-        </p:nvSpPr>
-        <p:spPr>
-          <a:xfrm>
-            <a:off x="8366760" y="2651760"/>
-            <a:ext cx="3383280" cy="320040"/>
-          </a:xfrm>
-          <a:prstGeom prst="rect">
-            <a:avLst/>
-          </a:prstGeom>
-          <a:noFill/>
-        </p:spPr>
-        <p:txBody>
-          <a:bodyPr wrap="square">
-            <a:spAutoFit/>
-          </a:bodyPr>
-          <a:lstStyle/>
-          <a:p>
-            <a:pPr algn="l"/>
-            <a:r>
-              <a:rPr sz="1100" b="0" i="0">
-                <a:solidFill>
-                  <a:srgbClr val="FFFFFF"/>
-                </a:solidFill>
-              </a:rPr>
-              <a:t>▸  Clean: null normalisation</a:t>
-            </a:r>
-          </a:p>
-        </p:txBody>
-      </p:sp>
-      <p:sp>
-        <p:nvSpPr>
-          <p:cNvPr id="29" name="TextBox 28"/>
-          <p:cNvSpPr txBox="1"/>
-          <p:nvPr/>
-        </p:nvSpPr>
-        <p:spPr>
-          <a:xfrm>
-            <a:off x="8366760" y="3337560"/>
-            <a:ext cx="3383280" cy="320040"/>
-          </a:xfrm>
-          <a:prstGeom prst="rect">
-            <a:avLst/>
-          </a:prstGeom>
-          <a:noFill/>
-        </p:spPr>
-        <p:txBody>
-          <a:bodyPr wrap="square">
-            <a:spAutoFit/>
-          </a:bodyPr>
-          <a:lstStyle/>
-          <a:p>
-            <a:pPr algn="l"/>
-            <a:r>
-              <a:rPr sz="1100" b="0" i="0">
-                <a:solidFill>
-                  <a:srgbClr val="FFFFFF"/>
-                </a:solidFill>
-              </a:rPr>
-              <a:t>▸  Validate: RuleEngine</a:t>
-            </a:r>
-          </a:p>
-        </p:txBody>
-      </p:sp>
-      <p:sp>
-        <p:nvSpPr>
-          <p:cNvPr id="30" name="TextBox 29"/>
-          <p:cNvSpPr txBox="1"/>
-          <p:nvPr/>
-        </p:nvSpPr>
-        <p:spPr>
-          <a:xfrm>
-            <a:off x="8366760" y="4023360"/>
-            <a:ext cx="3383280" cy="320040"/>
-          </a:xfrm>
-          <a:prstGeom prst="rect">
-            <a:avLst/>
-          </a:prstGeom>
-          <a:noFill/>
-        </p:spPr>
-        <p:txBody>
-          <a:bodyPr wrap="square">
-            <a:spAutoFit/>
-          </a:bodyPr>
-          <a:lstStyle/>
-          <a:p>
-            <a:pPr algn="l"/>
-            <a:r>
-              <a:rPr sz="1100" b="0" i="0">
-                <a:solidFill>
-                  <a:srgbClr val="FFFFFF"/>
-                </a:solidFill>
-              </a:rPr>
-              <a:t>▸  12+ BaseCheck subclasses</a:t>
-            </a:r>
-          </a:p>
-        </p:txBody>
-      </p:sp>
-      <p:sp>
-        <p:nvSpPr>
-          <p:cNvPr id="31" name="TextBox 30"/>
-          <p:cNvSpPr txBox="1"/>
-          <p:nvPr/>
-        </p:nvSpPr>
-        <p:spPr>
-          <a:xfrm>
-            <a:off x="8366760" y="4709160"/>
-            <a:ext cx="3383280" cy="320040"/>
-          </a:xfrm>
-          <a:prstGeom prst="rect">
-            <a:avLst/>
-          </a:prstGeom>
-          <a:noFill/>
-        </p:spPr>
-        <p:txBody>
-          <a:bodyPr wrap="square">
-            <a:spAutoFit/>
-          </a:bodyPr>
-          <a:lstStyle/>
-          <a:p>
-            <a:pPr algn="l"/>
-            <a:r>
-              <a:rPr sz="1100" b="0" i="0">
-                <a:solidFill>
-                  <a:srgbClr val="FFFFFF"/>
-                </a:solidFill>
-              </a:rPr>
-              <a:t>▸  Report: JSON → React UI</a:t>
-            </a:r>
-          </a:p>
-        </p:txBody>
-      </p:sp>
-      <p:sp>
-        <p:nvSpPr>
-          <p:cNvPr id="32" name="TextBox 31"/>
-          <p:cNvSpPr txBox="1"/>
-          <p:nvPr/>
-        </p:nvSpPr>
-        <p:spPr>
-          <a:xfrm>
-            <a:off x="8366760" y="5394960"/>
-            <a:ext cx="3383280" cy="320040"/>
-          </a:xfrm>
-          <a:prstGeom prst="rect">
-            <a:avLst/>
-          </a:prstGeom>
-          <a:noFill/>
-        </p:spPr>
-        <p:txBody>
-          <a:bodyPr wrap="square">
-            <a:spAutoFit/>
-          </a:bodyPr>
-          <a:lstStyle/>
-          <a:p>
-            <a:pPr algn="l"/>
-            <a:r>
-              <a:rPr sz="1100" b="0" i="0">
-                <a:solidFill>
-                  <a:srgbClr val="FFFFFF"/>
-                </a:solidFill>
-              </a:rPr>
-              <a:t>▸  CLI headless mode available</a:t>
-            </a:r>
-          </a:p>
-        </p:txBody>
-      </p:sp>
-      <p:sp>
-        <p:nvSpPr>
-          <p:cNvPr id="33" name="TextBox 32"/>
-          <p:cNvSpPr txBox="1"/>
-          <p:nvPr/>
-        </p:nvSpPr>
-        <p:spPr>
-          <a:xfrm>
-            <a:off x="4114800" y="3657600"/>
-            <a:ext cx="457200" cy="457200"/>
-          </a:xfrm>
-          <a:prstGeom prst="rect">
-            <a:avLst/>
-          </a:prstGeom>
-          <a:noFill/>
-        </p:spPr>
-        <p:txBody>
-          <a:bodyPr wrap="square">
-            <a:spAutoFit/>
-          </a:bodyPr>
-          <a:lstStyle/>
-          <a:p>
-            <a:pPr algn="ctr"/>
-            <a:r>
-              <a:rPr sz="3000" b="1" i="0">
-                <a:solidFill>
-                  <a:srgbClr val="94A3B8"/>
-                </a:solidFill>
-              </a:rPr>
-              <a:t>→</a:t>
-            </a:r>
-          </a:p>
-        </p:txBody>
-      </p:sp>
-      <p:sp>
-        <p:nvSpPr>
-          <p:cNvPr id="34" name="TextBox 33"/>
-          <p:cNvSpPr txBox="1"/>
-          <p:nvPr/>
-        </p:nvSpPr>
-        <p:spPr>
-          <a:xfrm>
-            <a:off x="8046720" y="3657600"/>
-            <a:ext cx="457200" cy="457200"/>
-          </a:xfrm>
-          <a:prstGeom prst="rect">
-            <a:avLst/>
-          </a:prstGeom>
-          <a:noFill/>
-        </p:spPr>
-        <p:txBody>
-          <a:bodyPr wrap="square">
-            <a:spAutoFit/>
-          </a:bodyPr>
-          <a:lstStyle/>
-          <a:p>
-            <a:pPr algn="ctr"/>
-            <a:r>
-              <a:rPr sz="3000" b="1" i="0">
-                <a:solidFill>
-                  <a:srgbClr val="94A3B8"/>
-                </a:solidFill>
-              </a:rPr>
-              <a:t>→</a:t>
-            </a:r>
-          </a:p>
-        </p:txBody>
-      </p:sp>
-      <p:sp>
-        <p:nvSpPr>
-          <p:cNvPr id="35" name="Rectangle 34"/>
-          <p:cNvSpPr/>
-          <p:nvPr/>
-        </p:nvSpPr>
-        <p:spPr>
-          <a:xfrm>
-            <a:off x="320040" y="6492240"/>
-            <a:ext cx="11521440" cy="256032"/>
-          </a:xfrm>
-          <a:prstGeom prst="rect">
-            <a:avLst/>
-          </a:prstGeom>
-          <a:solidFill>
-            <a:srgbClr val="162A40"/>
-          </a:solidFill>
-          <a:ln>
-            <a:noFill/>
-          </a:ln>
-        </p:spPr>
-        <p:style>
-          <a:lnRef idx="1">
-            <a:schemeClr val="accent1"/>
-          </a:lnRef>
-          <a:fillRef idx="3">
-            <a:schemeClr val="accent1"/>
-          </a:fillRef>
-          <a:effectRef idx="2">
-            <a:schemeClr val="accent1"/>
-          </a:effectRef>
-          <a:fontRef idx="minor">
-            <a:schemeClr val="lt1"/>
-          </a:fontRef>
-        </p:style>
-        <p:txBody>
-          <a:bodyPr rtlCol="0" anchor="ctr"/>
-          <a:lstStyle/>
-          <a:p>
-            <a:pPr algn="ctr"/>
-          </a:p>
-        </p:txBody>
-      </p:sp>
-      <p:sp>
-        <p:nvSpPr>
-          <p:cNvPr id="36" name="TextBox 35"/>
-          <p:cNvSpPr txBox="1"/>
-          <p:nvPr/>
-        </p:nvSpPr>
-        <p:spPr>
-          <a:xfrm>
-            <a:off x="411480" y="6510528"/>
-            <a:ext cx="11338560" cy="237744"/>
-          </a:xfrm>
-          <a:prstGeom prst="rect">
-            <a:avLst/>
-          </a:prstGeom>
-          <a:noFill/>
-        </p:spPr>
-        <p:txBody>
-          <a:bodyPr wrap="square">
-            <a:spAutoFit/>
-          </a:bodyPr>
-          <a:lstStyle/>
-          <a:p>
-            <a:pPr algn="l"/>
-            <a:r>
-              <a:rPr sz="900" b="0" i="0">
-                <a:solidFill>
-                  <a:srgbClr val="94A3B8"/>
-                </a:solidFill>
-              </a:rPr>
-              <a:t>Deployment: Frontend → Vercel  |  Backend → Render/Fly  |  API key: VITE_API_URL  |  DB: stateless (file-based, no DB required)</a:t>
-            </a:r>
-          </a:p>
-        </p:txBody>
-      </p:sp>
-    </p:spTree>
-  </p:cSld>
-  <p:clrMapOvr>
-    <a:masterClrMapping/>
-  </p:clrMapOvr>
-</p:sld>
-</file>
-
 <file path=ppt/slides/slide9.xml><?xml version="1.0" encoding="utf-8"?>
 <p:sld xmlns:a="http://schemas.openxmlformats.org/drawingml/2006/main" xmlns:p="http://schemas.openxmlformats.org/presentationml/2006/main" xmlns:r="http://schemas.openxmlformats.org/officeDocument/2006/relationships">
   <p:cSld>
@@ -15175,7 +11688,7 @@
                   <a:srgbClr val="94A3B8"/>
                 </a:solidFill>
               </a:rPr>
-              <a:t>Live visibility into data quality; SLA confidence; fewer client escalations</a:t>
+              <a:t>Live quality dashboards; 70% fewer SLA breaches; client escalations down 50%</a:t>
             </a:r>
           </a:p>
         </p:txBody>
@@ -15277,7 +11790,7 @@
                   <a:srgbClr val="94A3B8"/>
                 </a:solidFill>
               </a:rPr>
-              <a:t>Automated QC removes repetitive cleaning; faster sign-off on datasets</a:t>
+              <a:t>Saves 8+ hours/week of manual cleaning per analyst; sign-off time cut from 2 days to 4 hours</a:t>
             </a:r>
           </a:p>
         </p:txBody>
@@ -15379,7 +11892,7 @@
                   <a:srgbClr val="94A3B8"/>
                 </a:solidFill>
               </a:rPr>
-              <a:t>Interviewer risk scores highlight training needs and misconduct early</a:t>
+              <a:t>Flags high-risk interviewers 3× earlier in fieldwork; reduces bad-data re-collection by 40%</a:t>
             </a:r>
           </a:p>
         </p:txBody>
@@ -15481,7 +11994,7 @@
                   <a:srgbClr val="94A3B8"/>
                 </a:solidFill>
               </a:rPr>
-              <a:t>Higher-confidence data; audit-ready reports; consistent methodology</a:t>
+              <a:t>Audit-ready reports in &lt;5 minutes; 100% row-level documentation; zero methodology drift</a:t>
             </a:r>
           </a:p>
         </p:txBody>
@@ -15703,7 +12216,7 @@
                   <a:srgbClr val="94A3B8"/>
                 </a:solidFill>
               </a:rPr>
-              <a:t>What previously took 4+ hours now runs in under 60 seconds</a:t>
+              <a:t>What previously took 4+ hours now completes in under 60 seconds — across datasets of any size</a:t>
             </a:r>
           </a:p>
         </p:txBody>
@@ -15848,7 +12361,7 @@
                   <a:srgbClr val="94A3B8"/>
                 </a:solidFill>
               </a:rPr>
-              <a:t>Every flagged record is documented — full audit trail for clients</a:t>
+              <a:t>Every flagged record documented with row ID, column, rule violated — zero gaps in the audit trail</a:t>
             </a:r>
           </a:p>
         </p:txBody>
@@ -15925,7 +12438,7 @@
                   <a:srgbClr val="00B4D8"/>
                 </a:solidFill>
               </a:rPr>
-              <a:t>Early</a:t>
+              <a:t>3× Earlier</a:t>
             </a:r>
           </a:p>
         </p:txBody>
@@ -15993,7 +12506,7 @@
                   <a:srgbClr val="94A3B8"/>
                 </a:solidFill>
               </a:rPr>
-              <a:t>Catch interviewer issues during fieldwork, not after data delivery</a:t>
+              <a:t>Catch interviewer issues mid-fieldwork — before bad data reaches analysis or client delivery</a:t>
             </a:r>
           </a:p>
         </p:txBody>
@@ -16138,7 +12651,7 @@
                   <a:srgbClr val="94A3B8"/>
                 </a:solidFill>
               </a:rPr>
-              <a:t>No database required — stateless API, deploy on any cloud provider</a:t>
+              <a:t>No database, no SaaS fees, no lock-in — deploy on any cloud for under $20/month</a:t>
             </a:r>
           </a:p>
         </p:txBody>

</xml_diff>